<commit_message>
Add Transformer motivation bridge to speaker notes and script
Explains why the Transformer specifically was included: encountered the
architecture while studying uplift modeling and wanted to test it on raw
purchase sequences against the classical approaches.

Co-Authored-By: Claude Sonnet 5 <noreply@anthropic.com>
</commit_message>
<xml_diff>
--- a/presentation/presentation.pptx
+++ b/presentation/presentation.pptx
@@ -5,17 +5,17 @@
     <p:sldMasterId id="2147483648" r:id="rId1"/>
   </p:sldMasterIdLst>
   <p:sldIdLst>
-    <p:sldId id="256" r:id="rId7"/>
-    <p:sldId id="257" r:id="rId8"/>
-    <p:sldId id="258" r:id="rId9"/>
-    <p:sldId id="259" r:id="rId10"/>
-    <p:sldId id="260" r:id="rId11"/>
-    <p:sldId id="261" r:id="rId12"/>
-    <p:sldId id="262" r:id="rId13"/>
-    <p:sldId id="263" r:id="rId14"/>
-    <p:sldId id="264" r:id="rId15"/>
+    <p:sldId id="256" r:id="rId2"/>
+    <p:sldId id="257" r:id="rId3"/>
+    <p:sldId id="258" r:id="rId4"/>
+    <p:sldId id="259" r:id="rId5"/>
+    <p:sldId id="260" r:id="rId6"/>
+    <p:sldId id="261" r:id="rId7"/>
+    <p:sldId id="262" r:id="rId8"/>
+    <p:sldId id="263" r:id="rId9"/>
+    <p:sldId id="264" r:id="rId10"/>
   </p:sldIdLst>
-  <p:sldSz cx="12191695" cy="6858000" type="screen4x3"/>
+  <p:sldSz cx="12192000" cy="6858000"/>
   <p:notesSz cx="6858000" cy="9144000"/>
   <p:defaultTextStyle>
     <a:defPPr>
@@ -112,6 +112,22 @@
       </a:defRPr>
     </a:lvl9pPr>
   </p:defaultTextStyle>
+  <p:extLst>
+    <p:ext uri="{EFAFB233-063F-42B5-8137-9DF3F51BA10A}">
+      <p15:sldGuideLst xmlns:p15="http://schemas.microsoft.com/office/powerpoint/2012/main">
+        <p15:guide id="1" orient="horz" pos="2160">
+          <p15:clr>
+            <a:srgbClr val="A4A3A4"/>
+          </p15:clr>
+        </p15:guide>
+        <p15:guide id="2" pos="2880">
+          <p15:clr>
+            <a:srgbClr val="A4A3A4"/>
+          </p15:clr>
+        </p15:guide>
+      </p15:sldGuideLst>
+    </p:ext>
+  </p:extLst>
 </p:presentation>
 </file>
 
@@ -153,10 +169,9 @@
           <a:lstStyle/>
           <a:p>
             <a:r>
-              <a:rPr lang="en-US" smtClean="0"/>
+              <a:rPr lang="en-US"/>
               <a:t>Click to edit Master title style</a:t>
             </a:r>
-            <a:endParaRPr lang="en-US"/>
           </a:p>
         </p:txBody>
       </p:sp>
@@ -272,10 +287,9 @@
           </a:lstStyle>
           <a:p>
             <a:r>
-              <a:rPr lang="en-US" smtClean="0"/>
+              <a:rPr lang="en-US"/>
               <a:t>Click to edit Master subtitle style</a:t>
             </a:r>
-            <a:endParaRPr lang="en-US"/>
           </a:p>
         </p:txBody>
       </p:sp>
@@ -296,7 +310,7 @@
           <a:p>
             <a:fld id="{5BCAD085-E8A6-8845-BD4E-CB4CCA059FC4}" type="datetimeFigureOut">
               <a:rPr lang="en-US" smtClean="0"/>
-              <a:t>1/27/13</a:t>
+              <a:t>7/20/2026</a:t>
             </a:fld>
             <a:endParaRPr lang="en-US"/>
           </a:p>
@@ -390,10 +404,9 @@
           <a:lstStyle/>
           <a:p>
             <a:r>
-              <a:rPr lang="en-US" smtClean="0"/>
+              <a:rPr lang="en-US"/>
               <a:t>Click to edit Master title style</a:t>
             </a:r>
-            <a:endParaRPr lang="en-US"/>
           </a:p>
         </p:txBody>
       </p:sp>
@@ -414,38 +427,37 @@
           <a:p>
             <a:pPr lvl="0"/>
             <a:r>
-              <a:rPr lang="en-US" smtClean="0"/>
+              <a:rPr lang="en-US"/>
               <a:t>Click to edit Master text styles</a:t>
             </a:r>
           </a:p>
           <a:p>
             <a:pPr lvl="1"/>
             <a:r>
-              <a:rPr lang="en-US" smtClean="0"/>
+              <a:rPr lang="en-US"/>
               <a:t>Second level</a:t>
             </a:r>
           </a:p>
           <a:p>
             <a:pPr lvl="2"/>
             <a:r>
-              <a:rPr lang="en-US" smtClean="0"/>
+              <a:rPr lang="en-US"/>
               <a:t>Third level</a:t>
             </a:r>
           </a:p>
           <a:p>
             <a:pPr lvl="3"/>
             <a:r>
-              <a:rPr lang="en-US" smtClean="0"/>
+              <a:rPr lang="en-US"/>
               <a:t>Fourth level</a:t>
             </a:r>
           </a:p>
           <a:p>
             <a:pPr lvl="4"/>
             <a:r>
-              <a:rPr lang="en-US" smtClean="0"/>
+              <a:rPr lang="en-US"/>
               <a:t>Fifth level</a:t>
             </a:r>
-            <a:endParaRPr lang="en-US"/>
           </a:p>
         </p:txBody>
       </p:sp>
@@ -466,7 +478,7 @@
           <a:p>
             <a:fld id="{5BCAD085-E8A6-8845-BD4E-CB4CCA059FC4}" type="datetimeFigureOut">
               <a:rPr lang="en-US" smtClean="0"/>
-              <a:t>1/27/13</a:t>
+              <a:t>7/20/2026</a:t>
             </a:fld>
             <a:endParaRPr lang="en-US"/>
           </a:p>
@@ -565,10 +577,9 @@
           <a:lstStyle/>
           <a:p>
             <a:r>
-              <a:rPr lang="en-US" smtClean="0"/>
+              <a:rPr lang="en-US"/>
               <a:t>Click to edit Master title style</a:t>
             </a:r>
-            <a:endParaRPr lang="en-US"/>
           </a:p>
         </p:txBody>
       </p:sp>
@@ -594,38 +605,37 @@
           <a:p>
             <a:pPr lvl="0"/>
             <a:r>
-              <a:rPr lang="en-US" smtClean="0"/>
+              <a:rPr lang="en-US"/>
               <a:t>Click to edit Master text styles</a:t>
             </a:r>
           </a:p>
           <a:p>
             <a:pPr lvl="1"/>
             <a:r>
-              <a:rPr lang="en-US" smtClean="0"/>
+              <a:rPr lang="en-US"/>
               <a:t>Second level</a:t>
             </a:r>
           </a:p>
           <a:p>
             <a:pPr lvl="2"/>
             <a:r>
-              <a:rPr lang="en-US" smtClean="0"/>
+              <a:rPr lang="en-US"/>
               <a:t>Third level</a:t>
             </a:r>
           </a:p>
           <a:p>
             <a:pPr lvl="3"/>
             <a:r>
-              <a:rPr lang="en-US" smtClean="0"/>
+              <a:rPr lang="en-US"/>
               <a:t>Fourth level</a:t>
             </a:r>
           </a:p>
           <a:p>
             <a:pPr lvl="4"/>
             <a:r>
-              <a:rPr lang="en-US" smtClean="0"/>
+              <a:rPr lang="en-US"/>
               <a:t>Fifth level</a:t>
             </a:r>
-            <a:endParaRPr lang="en-US"/>
           </a:p>
         </p:txBody>
       </p:sp>
@@ -646,7 +656,7 @@
           <a:p>
             <a:fld id="{5BCAD085-E8A6-8845-BD4E-CB4CCA059FC4}" type="datetimeFigureOut">
               <a:rPr lang="en-US" smtClean="0"/>
-              <a:t>1/27/13</a:t>
+              <a:t>7/20/2026</a:t>
             </a:fld>
             <a:endParaRPr lang="en-US"/>
           </a:p>
@@ -740,10 +750,9 @@
           <a:lstStyle/>
           <a:p>
             <a:r>
-              <a:rPr lang="en-US" smtClean="0"/>
+              <a:rPr lang="en-US"/>
               <a:t>Click to edit Master title style</a:t>
             </a:r>
-            <a:endParaRPr lang="en-US"/>
           </a:p>
         </p:txBody>
       </p:sp>
@@ -764,38 +773,37 @@
           <a:p>
             <a:pPr lvl="0"/>
             <a:r>
-              <a:rPr lang="en-US" smtClean="0"/>
+              <a:rPr lang="en-US"/>
               <a:t>Click to edit Master text styles</a:t>
             </a:r>
           </a:p>
           <a:p>
             <a:pPr lvl="1"/>
             <a:r>
-              <a:rPr lang="en-US" smtClean="0"/>
+              <a:rPr lang="en-US"/>
               <a:t>Second level</a:t>
             </a:r>
           </a:p>
           <a:p>
             <a:pPr lvl="2"/>
             <a:r>
-              <a:rPr lang="en-US" smtClean="0"/>
+              <a:rPr lang="en-US"/>
               <a:t>Third level</a:t>
             </a:r>
           </a:p>
           <a:p>
             <a:pPr lvl="3"/>
             <a:r>
-              <a:rPr lang="en-US" smtClean="0"/>
+              <a:rPr lang="en-US"/>
               <a:t>Fourth level</a:t>
             </a:r>
           </a:p>
           <a:p>
             <a:pPr lvl="4"/>
             <a:r>
-              <a:rPr lang="en-US" smtClean="0"/>
+              <a:rPr lang="en-US"/>
               <a:t>Fifth level</a:t>
             </a:r>
-            <a:endParaRPr lang="en-US"/>
           </a:p>
         </p:txBody>
       </p:sp>
@@ -816,7 +824,7 @@
           <a:p>
             <a:fld id="{5BCAD085-E8A6-8845-BD4E-CB4CCA059FC4}" type="datetimeFigureOut">
               <a:rPr lang="en-US" smtClean="0"/>
-              <a:t>1/27/13</a:t>
+              <a:t>7/20/2026</a:t>
             </a:fld>
             <a:endParaRPr lang="en-US"/>
           </a:p>
@@ -919,10 +927,9 @@
           </a:lstStyle>
           <a:p>
             <a:r>
-              <a:rPr lang="en-US" smtClean="0"/>
+              <a:rPr lang="en-US"/>
               <a:t>Click to edit Master title style</a:t>
             </a:r>
-            <a:endParaRPr lang="en-US"/>
           </a:p>
         </p:txBody>
       </p:sp>
@@ -1039,7 +1046,7 @@
           <a:p>
             <a:pPr lvl="0"/>
             <a:r>
-              <a:rPr lang="en-US" smtClean="0"/>
+              <a:rPr lang="en-US"/>
               <a:t>Click to edit Master text styles</a:t>
             </a:r>
           </a:p>
@@ -1062,7 +1069,7 @@
           <a:p>
             <a:fld id="{5BCAD085-E8A6-8845-BD4E-CB4CCA059FC4}" type="datetimeFigureOut">
               <a:rPr lang="en-US" smtClean="0"/>
-              <a:t>1/27/13</a:t>
+              <a:t>7/20/2026</a:t>
             </a:fld>
             <a:endParaRPr lang="en-US"/>
           </a:p>
@@ -1156,10 +1163,9 @@
           <a:lstStyle/>
           <a:p>
             <a:r>
-              <a:rPr lang="en-US" smtClean="0"/>
+              <a:rPr lang="en-US"/>
               <a:t>Click to edit Master title style</a:t>
             </a:r>
-            <a:endParaRPr lang="en-US"/>
           </a:p>
         </p:txBody>
       </p:sp>
@@ -1213,38 +1219,37 @@
           <a:p>
             <a:pPr lvl="0"/>
             <a:r>
-              <a:rPr lang="en-US" smtClean="0"/>
+              <a:rPr lang="en-US"/>
               <a:t>Click to edit Master text styles</a:t>
             </a:r>
           </a:p>
           <a:p>
             <a:pPr lvl="1"/>
             <a:r>
-              <a:rPr lang="en-US" smtClean="0"/>
+              <a:rPr lang="en-US"/>
               <a:t>Second level</a:t>
             </a:r>
           </a:p>
           <a:p>
             <a:pPr lvl="2"/>
             <a:r>
-              <a:rPr lang="en-US" smtClean="0"/>
+              <a:rPr lang="en-US"/>
               <a:t>Third level</a:t>
             </a:r>
           </a:p>
           <a:p>
             <a:pPr lvl="3"/>
             <a:r>
-              <a:rPr lang="en-US" smtClean="0"/>
+              <a:rPr lang="en-US"/>
               <a:t>Fourth level</a:t>
             </a:r>
           </a:p>
           <a:p>
             <a:pPr lvl="4"/>
             <a:r>
-              <a:rPr lang="en-US" smtClean="0"/>
+              <a:rPr lang="en-US"/>
               <a:t>Fifth level</a:t>
             </a:r>
-            <a:endParaRPr lang="en-US"/>
           </a:p>
         </p:txBody>
       </p:sp>
@@ -1298,38 +1303,37 @@
           <a:p>
             <a:pPr lvl="0"/>
             <a:r>
-              <a:rPr lang="en-US" smtClean="0"/>
+              <a:rPr lang="en-US"/>
               <a:t>Click to edit Master text styles</a:t>
             </a:r>
           </a:p>
           <a:p>
             <a:pPr lvl="1"/>
             <a:r>
-              <a:rPr lang="en-US" smtClean="0"/>
+              <a:rPr lang="en-US"/>
               <a:t>Second level</a:t>
             </a:r>
           </a:p>
           <a:p>
             <a:pPr lvl="2"/>
             <a:r>
-              <a:rPr lang="en-US" smtClean="0"/>
+              <a:rPr lang="en-US"/>
               <a:t>Third level</a:t>
             </a:r>
           </a:p>
           <a:p>
             <a:pPr lvl="3"/>
             <a:r>
-              <a:rPr lang="en-US" smtClean="0"/>
+              <a:rPr lang="en-US"/>
               <a:t>Fourth level</a:t>
             </a:r>
           </a:p>
           <a:p>
             <a:pPr lvl="4"/>
             <a:r>
-              <a:rPr lang="en-US" smtClean="0"/>
+              <a:rPr lang="en-US"/>
               <a:t>Fifth level</a:t>
             </a:r>
-            <a:endParaRPr lang="en-US"/>
           </a:p>
         </p:txBody>
       </p:sp>
@@ -1350,7 +1354,7 @@
           <a:p>
             <a:fld id="{5BCAD085-E8A6-8845-BD4E-CB4CCA059FC4}" type="datetimeFigureOut">
               <a:rPr lang="en-US" smtClean="0"/>
-              <a:t>1/27/13</a:t>
+              <a:t>7/20/2026</a:t>
             </a:fld>
             <a:endParaRPr lang="en-US"/>
           </a:p>
@@ -1448,10 +1452,9 @@
           </a:lstStyle>
           <a:p>
             <a:r>
-              <a:rPr lang="en-US" smtClean="0"/>
+              <a:rPr lang="en-US"/>
               <a:t>Click to edit Master title style</a:t>
             </a:r>
-            <a:endParaRPr lang="en-US"/>
           </a:p>
         </p:txBody>
       </p:sp>
@@ -1514,7 +1517,7 @@
           <a:p>
             <a:pPr lvl="0"/>
             <a:r>
-              <a:rPr lang="en-US" smtClean="0"/>
+              <a:rPr lang="en-US"/>
               <a:t>Click to edit Master text styles</a:t>
             </a:r>
           </a:p>
@@ -1570,38 +1573,37 @@
           <a:p>
             <a:pPr lvl="0"/>
             <a:r>
-              <a:rPr lang="en-US" smtClean="0"/>
+              <a:rPr lang="en-US"/>
               <a:t>Click to edit Master text styles</a:t>
             </a:r>
           </a:p>
           <a:p>
             <a:pPr lvl="1"/>
             <a:r>
-              <a:rPr lang="en-US" smtClean="0"/>
+              <a:rPr lang="en-US"/>
               <a:t>Second level</a:t>
             </a:r>
           </a:p>
           <a:p>
             <a:pPr lvl="2"/>
             <a:r>
-              <a:rPr lang="en-US" smtClean="0"/>
+              <a:rPr lang="en-US"/>
               <a:t>Third level</a:t>
             </a:r>
           </a:p>
           <a:p>
             <a:pPr lvl="3"/>
             <a:r>
-              <a:rPr lang="en-US" smtClean="0"/>
+              <a:rPr lang="en-US"/>
               <a:t>Fourth level</a:t>
             </a:r>
           </a:p>
           <a:p>
             <a:pPr lvl="4"/>
             <a:r>
-              <a:rPr lang="en-US" smtClean="0"/>
+              <a:rPr lang="en-US"/>
               <a:t>Fifth level</a:t>
             </a:r>
-            <a:endParaRPr lang="en-US"/>
           </a:p>
         </p:txBody>
       </p:sp>
@@ -1664,7 +1666,7 @@
           <a:p>
             <a:pPr lvl="0"/>
             <a:r>
-              <a:rPr lang="en-US" smtClean="0"/>
+              <a:rPr lang="en-US"/>
               <a:t>Click to edit Master text styles</a:t>
             </a:r>
           </a:p>
@@ -1720,38 +1722,37 @@
           <a:p>
             <a:pPr lvl="0"/>
             <a:r>
-              <a:rPr lang="en-US" smtClean="0"/>
+              <a:rPr lang="en-US"/>
               <a:t>Click to edit Master text styles</a:t>
             </a:r>
           </a:p>
           <a:p>
             <a:pPr lvl="1"/>
             <a:r>
-              <a:rPr lang="en-US" smtClean="0"/>
+              <a:rPr lang="en-US"/>
               <a:t>Second level</a:t>
             </a:r>
           </a:p>
           <a:p>
             <a:pPr lvl="2"/>
             <a:r>
-              <a:rPr lang="en-US" smtClean="0"/>
+              <a:rPr lang="en-US"/>
               <a:t>Third level</a:t>
             </a:r>
           </a:p>
           <a:p>
             <a:pPr lvl="3"/>
             <a:r>
-              <a:rPr lang="en-US" smtClean="0"/>
+              <a:rPr lang="en-US"/>
               <a:t>Fourth level</a:t>
             </a:r>
           </a:p>
           <a:p>
             <a:pPr lvl="4"/>
             <a:r>
-              <a:rPr lang="en-US" smtClean="0"/>
+              <a:rPr lang="en-US"/>
               <a:t>Fifth level</a:t>
             </a:r>
-            <a:endParaRPr lang="en-US"/>
           </a:p>
         </p:txBody>
       </p:sp>
@@ -1772,7 +1773,7 @@
           <a:p>
             <a:fld id="{5BCAD085-E8A6-8845-BD4E-CB4CCA059FC4}" type="datetimeFigureOut">
               <a:rPr lang="en-US" smtClean="0"/>
-              <a:t>1/27/13</a:t>
+              <a:t>7/20/2026</a:t>
             </a:fld>
             <a:endParaRPr lang="en-US"/>
           </a:p>
@@ -1866,10 +1867,9 @@
           <a:lstStyle/>
           <a:p>
             <a:r>
-              <a:rPr lang="en-US" smtClean="0"/>
+              <a:rPr lang="en-US"/>
               <a:t>Click to edit Master title style</a:t>
             </a:r>
-            <a:endParaRPr lang="en-US"/>
           </a:p>
         </p:txBody>
       </p:sp>
@@ -1890,7 +1890,7 @@
           <a:p>
             <a:fld id="{5BCAD085-E8A6-8845-BD4E-CB4CCA059FC4}" type="datetimeFigureOut">
               <a:rPr lang="en-US" smtClean="0"/>
-              <a:t>1/27/13</a:t>
+              <a:t>7/20/2026</a:t>
             </a:fld>
             <a:endParaRPr lang="en-US"/>
           </a:p>
@@ -1985,7 +1985,7 @@
           <a:p>
             <a:fld id="{5BCAD085-E8A6-8845-BD4E-CB4CCA059FC4}" type="datetimeFigureOut">
               <a:rPr lang="en-US" smtClean="0"/>
-              <a:t>1/27/13</a:t>
+              <a:t>7/20/2026</a:t>
             </a:fld>
             <a:endParaRPr lang="en-US"/>
           </a:p>
@@ -2088,10 +2088,9 @@
           </a:lstStyle>
           <a:p>
             <a:r>
-              <a:rPr lang="en-US" smtClean="0"/>
+              <a:rPr lang="en-US"/>
               <a:t>Click to edit Master title style</a:t>
             </a:r>
-            <a:endParaRPr lang="en-US"/>
           </a:p>
         </p:txBody>
       </p:sp>
@@ -2145,38 +2144,37 @@
           <a:p>
             <a:pPr lvl="0"/>
             <a:r>
-              <a:rPr lang="en-US" smtClean="0"/>
+              <a:rPr lang="en-US"/>
               <a:t>Click to edit Master text styles</a:t>
             </a:r>
           </a:p>
           <a:p>
             <a:pPr lvl="1"/>
             <a:r>
-              <a:rPr lang="en-US" smtClean="0"/>
+              <a:rPr lang="en-US"/>
               <a:t>Second level</a:t>
             </a:r>
           </a:p>
           <a:p>
             <a:pPr lvl="2"/>
             <a:r>
-              <a:rPr lang="en-US" smtClean="0"/>
+              <a:rPr lang="en-US"/>
               <a:t>Third level</a:t>
             </a:r>
           </a:p>
           <a:p>
             <a:pPr lvl="3"/>
             <a:r>
-              <a:rPr lang="en-US" smtClean="0"/>
+              <a:rPr lang="en-US"/>
               <a:t>Fourth level</a:t>
             </a:r>
           </a:p>
           <a:p>
             <a:pPr lvl="4"/>
             <a:r>
-              <a:rPr lang="en-US" smtClean="0"/>
+              <a:rPr lang="en-US"/>
               <a:t>Fifth level</a:t>
             </a:r>
-            <a:endParaRPr lang="en-US"/>
           </a:p>
         </p:txBody>
       </p:sp>
@@ -2239,7 +2237,7 @@
           <a:p>
             <a:pPr lvl="0"/>
             <a:r>
-              <a:rPr lang="en-US" smtClean="0"/>
+              <a:rPr lang="en-US"/>
               <a:t>Click to edit Master text styles</a:t>
             </a:r>
           </a:p>
@@ -2262,7 +2260,7 @@
           <a:p>
             <a:fld id="{5BCAD085-E8A6-8845-BD4E-CB4CCA059FC4}" type="datetimeFigureOut">
               <a:rPr lang="en-US" smtClean="0"/>
-              <a:t>1/27/13</a:t>
+              <a:t>7/20/2026</a:t>
             </a:fld>
             <a:endParaRPr lang="en-US"/>
           </a:p>
@@ -2365,10 +2363,9 @@
           </a:lstStyle>
           <a:p>
             <a:r>
-              <a:rPr lang="en-US" smtClean="0"/>
+              <a:rPr lang="en-US"/>
               <a:t>Click to edit Master title style</a:t>
             </a:r>
-            <a:endParaRPr lang="en-US"/>
           </a:p>
         </p:txBody>
       </p:sp>
@@ -2492,7 +2489,7 @@
           <a:p>
             <a:pPr lvl="0"/>
             <a:r>
-              <a:rPr lang="en-US" smtClean="0"/>
+              <a:rPr lang="en-US"/>
               <a:t>Click to edit Master text styles</a:t>
             </a:r>
           </a:p>
@@ -2515,7 +2512,7 @@
           <a:p>
             <a:fld id="{5BCAD085-E8A6-8845-BD4E-CB4CCA059FC4}" type="datetimeFigureOut">
               <a:rPr lang="en-US" smtClean="0"/>
-              <a:t>1/27/13</a:t>
+              <a:t>7/20/2026</a:t>
             </a:fld>
             <a:endParaRPr lang="en-US"/>
           </a:p>
@@ -2624,10 +2621,9 @@
           <a:lstStyle/>
           <a:p>
             <a:r>
-              <a:rPr lang="en-US" smtClean="0"/>
+              <a:rPr lang="en-US"/>
               <a:t>Click to edit Master title style</a:t>
             </a:r>
-            <a:endParaRPr lang="en-US"/>
           </a:p>
         </p:txBody>
       </p:sp>
@@ -2658,38 +2654,37 @@
           <a:p>
             <a:pPr lvl="0"/>
             <a:r>
-              <a:rPr lang="en-US" smtClean="0"/>
+              <a:rPr lang="en-US"/>
               <a:t>Click to edit Master text styles</a:t>
             </a:r>
           </a:p>
           <a:p>
             <a:pPr lvl="1"/>
             <a:r>
-              <a:rPr lang="en-US" smtClean="0"/>
+              <a:rPr lang="en-US"/>
               <a:t>Second level</a:t>
             </a:r>
           </a:p>
           <a:p>
             <a:pPr lvl="2"/>
             <a:r>
-              <a:rPr lang="en-US" smtClean="0"/>
+              <a:rPr lang="en-US"/>
               <a:t>Third level</a:t>
             </a:r>
           </a:p>
           <a:p>
             <a:pPr lvl="3"/>
             <a:r>
-              <a:rPr lang="en-US" smtClean="0"/>
+              <a:rPr lang="en-US"/>
               <a:t>Fourth level</a:t>
             </a:r>
           </a:p>
           <a:p>
             <a:pPr lvl="4"/>
             <a:r>
-              <a:rPr lang="en-US" smtClean="0"/>
+              <a:rPr lang="en-US"/>
               <a:t>Fifth level</a:t>
             </a:r>
-            <a:endParaRPr lang="en-US"/>
           </a:p>
         </p:txBody>
       </p:sp>
@@ -2728,7 +2723,7 @@
           <a:p>
             <a:fld id="{5BCAD085-E8A6-8845-BD4E-CB4CCA059FC4}" type="datetimeFigureOut">
               <a:rPr lang="en-US" smtClean="0"/>
-              <a:t>1/27/13</a:t>
+              <a:t>7/20/2026</a:t>
             </a:fld>
             <a:endParaRPr lang="en-US"/>
           </a:p>
@@ -3087,7 +3082,7 @@
 </file>
 
 <file path=ppt/slides/slide1.xml><?xml version="1.0" encoding="utf-8"?>
-<p:sld xmlns:a="http://schemas.openxmlformats.org/drawingml/2006/main" xmlns:p="http://schemas.openxmlformats.org/presentationml/2006/main" xmlns:r="http://schemas.openxmlformats.org/officeDocument/2006/relationships">
+<p:sld xmlns:a="http://schemas.openxmlformats.org/drawingml/2006/main" xmlns:r="http://schemas.openxmlformats.org/officeDocument/2006/relationships" xmlns:p="http://schemas.openxmlformats.org/presentationml/2006/main">
   <p:cSld>
     <p:bg>
       <p:bgPr>
@@ -3103,7 +3098,14 @@
         <p:cNvGrpSpPr/>
         <p:nvPr/>
       </p:nvGrpSpPr>
-      <p:grpSpPr/>
+      <p:grpSpPr>
+        <a:xfrm>
+          <a:off x="0" y="0"/>
+          <a:ext cx="0" cy="0"/>
+          <a:chOff x="0" y="0"/>
+          <a:chExt cx="0" cy="0"/>
+        </a:xfrm>
+      </p:grpSpPr>
       <p:sp>
         <p:nvSpPr>
           <p:cNvPr id="2" name="Rectangle 1"/>
@@ -3145,6 +3147,7 @@
           <a:lstStyle/>
           <a:p>
             <a:pPr algn="ctr"/>
+            <a:endParaRPr/>
           </a:p>
         </p:txBody>
       </p:sp>
@@ -3189,6 +3192,7 @@
           <a:lstStyle/>
           <a:p>
             <a:pPr algn="ctr"/>
+            <a:endParaRPr/>
           </a:p>
         </p:txBody>
       </p:sp>
@@ -3233,6 +3237,7 @@
           <a:lstStyle/>
           <a:p>
             <a:pPr algn="ctr"/>
+            <a:endParaRPr/>
           </a:p>
         </p:txBody>
       </p:sp>
@@ -3277,6 +3282,7 @@
           <a:lstStyle/>
           <a:p>
             <a:pPr algn="ctr"/>
+            <a:endParaRPr/>
           </a:p>
         </p:txBody>
       </p:sp>
@@ -3321,6 +3327,7 @@
           <a:lstStyle/>
           <a:p>
             <a:pPr algn="ctr"/>
+            <a:endParaRPr/>
           </a:p>
         </p:txBody>
       </p:sp>
@@ -3365,6 +3372,7 @@
           <a:lstStyle/>
           <a:p>
             <a:pPr algn="ctr"/>
+            <a:endParaRPr/>
           </a:p>
         </p:txBody>
       </p:sp>
@@ -3409,45 +3417,7 @@
           <a:lstStyle/>
           <a:p>
             <a:pPr algn="ctr"/>
-          </a:p>
-        </p:txBody>
-      </p:sp>
-      <p:sp>
-        <p:nvSpPr>
-          <p:cNvPr id="9" name="TextBox 8"/>
-          <p:cNvSpPr txBox="1"/>
-          <p:nvPr/>
-        </p:nvSpPr>
-        <p:spPr>
-          <a:xfrm>
-            <a:off x="8290352" y="5257800"/>
-            <a:ext cx="3657600" cy="320040"/>
-          </a:xfrm>
-          <a:prstGeom prst="rect">
-            <a:avLst/>
-          </a:prstGeom>
-          <a:noFill/>
-        </p:spPr>
-        <p:txBody>
-          <a:bodyPr wrap="square">
-            <a:spAutoFit/>
-          </a:bodyPr>
-          <a:lstStyle/>
-          <a:p>
-            <a:pPr algn="l">
-              <a:lnSpc>
-                <a:spcPct val="100000"/>
-              </a:lnSpc>
-            </a:pPr>
-            <a:r>
-              <a:rPr sz="1050" b="0" i="0">
-                <a:solidFill>
-                  <a:srgbClr val="A9B4C0"/>
-                </a:solidFill>
-                <a:latin typeface="Calibri"/>
-              </a:rPr>
-              <a:t>иллюстрация: прирост эффекта коммуникации</a:t>
-            </a:r>
+            <a:endParaRPr/>
           </a:p>
         </p:txBody>
       </p:sp>
@@ -3657,6 +3627,7 @@
           <a:lstStyle/>
           <a:p>
             <a:pPr algn="ctr"/>
+            <a:endParaRPr/>
           </a:p>
         </p:txBody>
       </p:sp>
@@ -3786,7 +3757,7 @@
 </file>
 
 <file path=ppt/slides/slide2.xml><?xml version="1.0" encoding="utf-8"?>
-<p:sld xmlns:a="http://schemas.openxmlformats.org/drawingml/2006/main" xmlns:p="http://schemas.openxmlformats.org/presentationml/2006/main" xmlns:r="http://schemas.openxmlformats.org/officeDocument/2006/relationships">
+<p:sld xmlns:a="http://schemas.openxmlformats.org/drawingml/2006/main" xmlns:r="http://schemas.openxmlformats.org/officeDocument/2006/relationships" xmlns:p="http://schemas.openxmlformats.org/presentationml/2006/main">
   <p:cSld>
     <p:bg>
       <p:bgPr>
@@ -3802,7 +3773,14 @@
         <p:cNvGrpSpPr/>
         <p:nvPr/>
       </p:nvGrpSpPr>
-      <p:grpSpPr/>
+      <p:grpSpPr>
+        <a:xfrm>
+          <a:off x="0" y="0"/>
+          <a:ext cx="0" cy="0"/>
+          <a:chOff x="0" y="0"/>
+          <a:chExt cx="0" cy="0"/>
+        </a:xfrm>
+      </p:grpSpPr>
       <p:sp>
         <p:nvSpPr>
           <p:cNvPr id="2" name="Rectangle 1"/>
@@ -3844,6 +3822,7 @@
           <a:lstStyle/>
           <a:p>
             <a:pPr algn="ctr"/>
+            <a:endParaRPr/>
           </a:p>
         </p:txBody>
       </p:sp>
@@ -4009,6 +3988,7 @@
           <a:lstStyle/>
           <a:p>
             <a:pPr algn="ctr"/>
+            <a:endParaRPr/>
           </a:p>
         </p:txBody>
       </p:sp>
@@ -4053,6 +4033,7 @@
           <a:lstStyle/>
           <a:p>
             <a:pPr algn="ctr"/>
+            <a:endParaRPr/>
           </a:p>
         </p:txBody>
       </p:sp>
@@ -4170,15 +4151,12 @@
                 <a:spcPct val="108000"/>
               </a:lnSpc>
             </a:pPr>
-            <a:r>
-              <a:rPr sz="1300" b="0" i="0">
-                <a:solidFill>
-                  <a:srgbClr val="A9B4C0"/>
-                </a:solidFill>
-                <a:latin typeface="Calibri"/>
-              </a:rPr>
-              <a:t/>
-            </a:r>
+            <a:endParaRPr sz="1300" b="0" i="0">
+              <a:solidFill>
+                <a:srgbClr val="A9B4C0"/>
+              </a:solidFill>
+              <a:latin typeface="Calibri"/>
+            </a:endParaRPr>
           </a:p>
           <a:p>
             <a:pPr algn="l">
@@ -4291,6 +4269,7 @@
           <a:lstStyle/>
           <a:p>
             <a:pPr algn="ctr"/>
+            <a:endParaRPr/>
           </a:p>
         </p:txBody>
       </p:sp>
@@ -4335,6 +4314,7 @@
           <a:lstStyle/>
           <a:p>
             <a:pPr algn="ctr"/>
+            <a:endParaRPr/>
           </a:p>
         </p:txBody>
       </p:sp>
@@ -4420,15 +4400,12 @@
                 <a:spcPct val="108000"/>
               </a:lnSpc>
             </a:pPr>
-            <a:r>
-              <a:rPr sz="1350" b="0" i="0">
-                <a:solidFill>
-                  <a:srgbClr val="A9B4C0"/>
-                </a:solidFill>
-                <a:latin typeface="Calibri"/>
-              </a:rPr>
-              <a:t/>
-            </a:r>
+            <a:endParaRPr sz="1350" b="0" i="0">
+              <a:solidFill>
+                <a:srgbClr val="A9B4C0"/>
+              </a:solidFill>
+              <a:latin typeface="Calibri"/>
+            </a:endParaRPr>
           </a:p>
           <a:p>
             <a:pPr algn="l">
@@ -4493,6 +4470,7 @@
           <a:lstStyle/>
           <a:p>
             <a:pPr algn="ctr"/>
+            <a:endParaRPr/>
           </a:p>
         </p:txBody>
       </p:sp>
@@ -4537,6 +4515,7 @@
           <a:lstStyle/>
           <a:p>
             <a:pPr algn="ctr"/>
+            <a:endParaRPr/>
           </a:p>
         </p:txBody>
       </p:sp>
@@ -4654,15 +4633,12 @@
                 <a:spcPct val="108000"/>
               </a:lnSpc>
             </a:pPr>
-            <a:r>
-              <a:rPr sz="1300" b="0" i="0">
-                <a:solidFill>
-                  <a:srgbClr val="A9B4C0"/>
-                </a:solidFill>
-                <a:latin typeface="Calibri"/>
-              </a:rPr>
-              <a:t/>
-            </a:r>
+            <a:endParaRPr sz="1300" b="0" i="0">
+              <a:solidFill>
+                <a:srgbClr val="A9B4C0"/>
+              </a:solidFill>
+              <a:latin typeface="Calibri"/>
+            </a:endParaRPr>
           </a:p>
           <a:p>
             <a:pPr algn="l">
@@ -4723,6 +4699,7 @@
           <a:lstStyle/>
           <a:p>
             <a:pPr algn="ctr"/>
+            <a:endParaRPr/>
           </a:p>
         </p:txBody>
       </p:sp>
@@ -4767,6 +4744,7 @@
           <a:lstStyle/>
           <a:p>
             <a:pPr algn="ctr"/>
+            <a:endParaRPr/>
           </a:p>
         </p:txBody>
       </p:sp>
@@ -4779,7 +4757,7 @@
         <p:spPr>
           <a:xfrm>
             <a:off x="502920" y="6080760"/>
-            <a:ext cx="11185855" cy="457200"/>
+            <a:ext cx="11185855" cy="284693"/>
           </a:xfrm>
           <a:prstGeom prst="rect">
             <a:avLst/>
@@ -4798,13 +4776,112 @@
               </a:lnSpc>
             </a:pPr>
             <a:r>
-              <a:rPr sz="1250" b="0" i="1">
-                <a:solidFill>
-                  <a:srgbClr val="A9B4C0"/>
-                </a:solidFill>
-                <a:latin typeface="Calibri"/>
-              </a:rPr>
-              <a:t>Проект выполнен на открытых данных X5 RetailHero. Данные, код и внутренние результаты Т-Банка не использовались.</a:t>
+              <a:rPr sz="1250" b="0" i="1" dirty="0" err="1">
+                <a:solidFill>
+                  <a:srgbClr val="A9B4C0"/>
+                </a:solidFill>
+                <a:latin typeface="Calibri"/>
+              </a:rPr>
+              <a:t>Проект</a:t>
+            </a:r>
+            <a:r>
+              <a:rPr sz="1250" b="0" i="1" dirty="0">
+                <a:solidFill>
+                  <a:srgbClr val="A9B4C0"/>
+                </a:solidFill>
+                <a:latin typeface="Calibri"/>
+              </a:rPr>
+              <a:t> </a:t>
+            </a:r>
+            <a:r>
+              <a:rPr sz="1250" b="0" i="1" dirty="0" err="1">
+                <a:solidFill>
+                  <a:srgbClr val="A9B4C0"/>
+                </a:solidFill>
+                <a:latin typeface="Calibri"/>
+              </a:rPr>
+              <a:t>выполнен</a:t>
+            </a:r>
+            <a:r>
+              <a:rPr sz="1250" b="0" i="1" dirty="0">
+                <a:solidFill>
+                  <a:srgbClr val="A9B4C0"/>
+                </a:solidFill>
+                <a:latin typeface="Calibri"/>
+              </a:rPr>
+              <a:t> </a:t>
+            </a:r>
+            <a:r>
+              <a:rPr sz="1250" b="0" i="1" dirty="0" err="1">
+                <a:solidFill>
+                  <a:srgbClr val="A9B4C0"/>
+                </a:solidFill>
+                <a:latin typeface="Calibri"/>
+              </a:rPr>
+              <a:t>на</a:t>
+            </a:r>
+            <a:r>
+              <a:rPr sz="1250" b="0" i="1" dirty="0">
+                <a:solidFill>
+                  <a:srgbClr val="A9B4C0"/>
+                </a:solidFill>
+                <a:latin typeface="Calibri"/>
+              </a:rPr>
+              <a:t> </a:t>
+            </a:r>
+            <a:r>
+              <a:rPr sz="1250" b="0" i="1" dirty="0" err="1">
+                <a:solidFill>
+                  <a:srgbClr val="A9B4C0"/>
+                </a:solidFill>
+                <a:latin typeface="Calibri"/>
+              </a:rPr>
+              <a:t>открытых</a:t>
+            </a:r>
+            <a:r>
+              <a:rPr sz="1250" b="0" i="1" dirty="0">
+                <a:solidFill>
+                  <a:srgbClr val="A9B4C0"/>
+                </a:solidFill>
+                <a:latin typeface="Calibri"/>
+              </a:rPr>
+              <a:t> </a:t>
+            </a:r>
+            <a:r>
+              <a:rPr sz="1250" b="0" i="1" dirty="0" err="1">
+                <a:solidFill>
+                  <a:srgbClr val="A9B4C0"/>
+                </a:solidFill>
+                <a:latin typeface="Calibri"/>
+              </a:rPr>
+              <a:t>данных</a:t>
+            </a:r>
+            <a:r>
+              <a:rPr sz="1250" b="0" i="1" dirty="0">
+                <a:solidFill>
+                  <a:srgbClr val="A9B4C0"/>
+                </a:solidFill>
+                <a:latin typeface="Calibri"/>
+              </a:rPr>
+              <a:t> X5 </a:t>
+            </a:r>
+            <a:r>
+              <a:rPr sz="1250" b="0" i="1" dirty="0" err="1">
+                <a:solidFill>
+                  <a:srgbClr val="A9B4C0"/>
+                </a:solidFill>
+                <a:latin typeface="Calibri"/>
+              </a:rPr>
+              <a:t>RetailHero</a:t>
+            </a:r>
+            <a:r>
+              <a:rPr sz="1250" b="0" i="1" dirty="0">
+                <a:solidFill>
+                  <a:srgbClr val="A9B4C0"/>
+                </a:solidFill>
+                <a:latin typeface="Calibri"/>
+              </a:rPr>
+              <a:t>. </a:t>
             </a:r>
           </a:p>
         </p:txBody>
@@ -4850,6 +4927,7 @@
           <a:lstStyle/>
           <a:p>
             <a:pPr algn="ctr"/>
+            <a:endParaRPr/>
           </a:p>
         </p:txBody>
       </p:sp>
@@ -4940,7 +5018,7 @@
 </file>
 
 <file path=ppt/slides/slide3.xml><?xml version="1.0" encoding="utf-8"?>
-<p:sld xmlns:a="http://schemas.openxmlformats.org/drawingml/2006/main" xmlns:p="http://schemas.openxmlformats.org/presentationml/2006/main" xmlns:r="http://schemas.openxmlformats.org/officeDocument/2006/relationships">
+<p:sld xmlns:a="http://schemas.openxmlformats.org/drawingml/2006/main" xmlns:r="http://schemas.openxmlformats.org/officeDocument/2006/relationships" xmlns:p="http://schemas.openxmlformats.org/presentationml/2006/main">
   <p:cSld>
     <p:bg>
       <p:bgPr>
@@ -4956,7 +5034,14 @@
         <p:cNvGrpSpPr/>
         <p:nvPr/>
       </p:nvGrpSpPr>
-      <p:grpSpPr/>
+      <p:grpSpPr>
+        <a:xfrm>
+          <a:off x="0" y="0"/>
+          <a:ext cx="0" cy="0"/>
+          <a:chOff x="0" y="0"/>
+          <a:chExt cx="0" cy="0"/>
+        </a:xfrm>
+      </p:grpSpPr>
       <p:sp>
         <p:nvSpPr>
           <p:cNvPr id="2" name="Rectangle 1"/>
@@ -4998,6 +5083,7 @@
           <a:lstStyle/>
           <a:p>
             <a:pPr algn="ctr"/>
+            <a:endParaRPr/>
           </a:p>
         </p:txBody>
       </p:sp>
@@ -5163,6 +5249,7 @@
           <a:lstStyle/>
           <a:p>
             <a:pPr algn="ctr"/>
+            <a:endParaRPr/>
           </a:p>
         </p:txBody>
       </p:sp>
@@ -5207,6 +5294,7 @@
           <a:lstStyle/>
           <a:p>
             <a:pPr algn="ctr"/>
+            <a:endParaRPr/>
           </a:p>
         </p:txBody>
       </p:sp>
@@ -5333,6 +5421,7 @@
           <a:lstStyle/>
           <a:p>
             <a:pPr algn="ctr"/>
+            <a:endParaRPr/>
           </a:p>
         </p:txBody>
       </p:sp>
@@ -5377,6 +5466,7 @@
           <a:lstStyle/>
           <a:p>
             <a:pPr algn="ctr"/>
+            <a:endParaRPr/>
           </a:p>
         </p:txBody>
       </p:sp>
@@ -5503,6 +5593,7 @@
           <a:lstStyle/>
           <a:p>
             <a:pPr algn="ctr"/>
+            <a:endParaRPr/>
           </a:p>
         </p:txBody>
       </p:sp>
@@ -5547,6 +5638,7 @@
           <a:lstStyle/>
           <a:p>
             <a:pPr algn="ctr"/>
+            <a:endParaRPr/>
           </a:p>
         </p:txBody>
       </p:sp>
@@ -5673,6 +5765,7 @@
           <a:lstStyle/>
           <a:p>
             <a:pPr algn="ctr"/>
+            <a:endParaRPr/>
           </a:p>
         </p:txBody>
       </p:sp>
@@ -5717,6 +5810,7 @@
           <a:lstStyle/>
           <a:p>
             <a:pPr algn="ctr"/>
+            <a:endParaRPr/>
           </a:p>
         </p:txBody>
       </p:sp>
@@ -5839,6 +5933,7 @@
           <a:lstStyle/>
           <a:p>
             <a:pPr algn="ctr"/>
+            <a:endParaRPr/>
           </a:p>
         </p:txBody>
       </p:sp>
@@ -5929,7 +6024,7 @@
 </file>
 
 <file path=ppt/slides/slide4.xml><?xml version="1.0" encoding="utf-8"?>
-<p:sld xmlns:a="http://schemas.openxmlformats.org/drawingml/2006/main" xmlns:p="http://schemas.openxmlformats.org/presentationml/2006/main" xmlns:r="http://schemas.openxmlformats.org/officeDocument/2006/relationships">
+<p:sld xmlns:a="http://schemas.openxmlformats.org/drawingml/2006/main" xmlns:r="http://schemas.openxmlformats.org/officeDocument/2006/relationships" xmlns:p="http://schemas.openxmlformats.org/presentationml/2006/main">
   <p:cSld>
     <p:bg>
       <p:bgPr>
@@ -5945,7 +6040,14 @@
         <p:cNvGrpSpPr/>
         <p:nvPr/>
       </p:nvGrpSpPr>
-      <p:grpSpPr/>
+      <p:grpSpPr>
+        <a:xfrm>
+          <a:off x="0" y="0"/>
+          <a:ext cx="0" cy="0"/>
+          <a:chOff x="0" y="0"/>
+          <a:chExt cx="0" cy="0"/>
+        </a:xfrm>
+      </p:grpSpPr>
       <p:sp>
         <p:nvSpPr>
           <p:cNvPr id="2" name="Rectangle 1"/>
@@ -5987,6 +6089,7 @@
           <a:lstStyle/>
           <a:p>
             <a:pPr algn="ctr"/>
+            <a:endParaRPr/>
           </a:p>
         </p:txBody>
       </p:sp>
@@ -6152,6 +6255,7 @@
           <a:lstStyle/>
           <a:p>
             <a:pPr algn="ctr"/>
+            <a:endParaRPr/>
           </a:p>
         </p:txBody>
       </p:sp>
@@ -6196,6 +6300,7 @@
           <a:lstStyle/>
           <a:p>
             <a:pPr algn="ctr"/>
+            <a:endParaRPr/>
           </a:p>
         </p:txBody>
       </p:sp>
@@ -6361,6 +6466,7 @@
           <a:lstStyle/>
           <a:p>
             <a:pPr algn="ctr"/>
+            <a:endParaRPr/>
           </a:p>
         </p:txBody>
       </p:sp>
@@ -6405,6 +6511,7 @@
           <a:lstStyle/>
           <a:p>
             <a:pPr algn="ctr"/>
+            <a:endParaRPr/>
           </a:p>
         </p:txBody>
       </p:sp>
@@ -6570,6 +6677,7 @@
           <a:lstStyle/>
           <a:p>
             <a:pPr algn="ctr"/>
+            <a:endParaRPr/>
           </a:p>
         </p:txBody>
       </p:sp>
@@ -6614,6 +6722,7 @@
           <a:lstStyle/>
           <a:p>
             <a:pPr algn="ctr"/>
+            <a:endParaRPr/>
           </a:p>
         </p:txBody>
       </p:sp>
@@ -6779,6 +6888,7 @@
           <a:lstStyle/>
           <a:p>
             <a:pPr algn="ctr"/>
+            <a:endParaRPr/>
           </a:p>
         </p:txBody>
       </p:sp>
@@ -6823,6 +6933,7 @@
           <a:lstStyle/>
           <a:p>
             <a:pPr algn="ctr"/>
+            <a:endParaRPr/>
           </a:p>
         </p:txBody>
       </p:sp>
@@ -6988,6 +7099,7 @@
           <a:lstStyle/>
           <a:p>
             <a:pPr algn="ctr"/>
+            <a:endParaRPr/>
           </a:p>
         </p:txBody>
       </p:sp>
@@ -7032,6 +7144,7 @@
           <a:lstStyle/>
           <a:p>
             <a:pPr algn="ctr"/>
+            <a:endParaRPr/>
           </a:p>
         </p:txBody>
       </p:sp>
@@ -7154,6 +7267,7 @@
           <a:lstStyle/>
           <a:p>
             <a:pPr algn="ctr"/>
+            <a:endParaRPr/>
           </a:p>
         </p:txBody>
       </p:sp>
@@ -7244,7 +7358,7 @@
 </file>
 
 <file path=ppt/slides/slide5.xml><?xml version="1.0" encoding="utf-8"?>
-<p:sld xmlns:a="http://schemas.openxmlformats.org/drawingml/2006/main" xmlns:p="http://schemas.openxmlformats.org/presentationml/2006/main" xmlns:r="http://schemas.openxmlformats.org/officeDocument/2006/relationships">
+<p:sld xmlns:a="http://schemas.openxmlformats.org/drawingml/2006/main" xmlns:r="http://schemas.openxmlformats.org/officeDocument/2006/relationships" xmlns:p="http://schemas.openxmlformats.org/presentationml/2006/main">
   <p:cSld>
     <p:bg>
       <p:bgPr>
@@ -7260,7 +7374,14 @@
         <p:cNvGrpSpPr/>
         <p:nvPr/>
       </p:nvGrpSpPr>
-      <p:grpSpPr/>
+      <p:grpSpPr>
+        <a:xfrm>
+          <a:off x="0" y="0"/>
+          <a:ext cx="0" cy="0"/>
+          <a:chOff x="0" y="0"/>
+          <a:chExt cx="0" cy="0"/>
+        </a:xfrm>
+      </p:grpSpPr>
       <p:sp>
         <p:nvSpPr>
           <p:cNvPr id="2" name="Rectangle 1"/>
@@ -7302,6 +7423,7 @@
           <a:lstStyle/>
           <a:p>
             <a:pPr algn="ctr"/>
+            <a:endParaRPr/>
           </a:p>
         </p:txBody>
       </p:sp>
@@ -7467,6 +7589,7 @@
           <a:lstStyle/>
           <a:p>
             <a:pPr algn="ctr"/>
+            <a:endParaRPr/>
           </a:p>
         </p:txBody>
       </p:sp>
@@ -7511,6 +7634,7 @@
           <a:lstStyle/>
           <a:p>
             <a:pPr algn="ctr"/>
+            <a:endParaRPr/>
           </a:p>
         </p:txBody>
       </p:sp>
@@ -7523,7 +7647,7 @@
         <p:spPr>
           <a:xfrm>
             <a:off x="758952" y="2249424"/>
-            <a:ext cx="4943703" cy="438086"/>
+            <a:ext cx="4943703" cy="332720"/>
           </a:xfrm>
           <a:prstGeom prst="rect">
             <a:avLst/>
@@ -7542,13 +7666,22 @@
               </a:lnSpc>
             </a:pPr>
             <a:r>
-              <a:rPr sz="1550" b="1" i="0">
+              <a:rPr lang="ru-RU" sz="1550" b="1" dirty="0">
                 <a:solidFill>
                   <a:srgbClr val="F2F4F7"/>
                 </a:solidFill>
                 <a:latin typeface="Calibri"/>
               </a:rPr>
-              <a:t>0 · Random targeting</a:t>
+              <a:t>1</a:t>
+            </a:r>
+            <a:r>
+              <a:rPr sz="1550" b="1" i="0" dirty="0">
+                <a:solidFill>
+                  <a:srgbClr val="F2F4F7"/>
+                </a:solidFill>
+                <a:latin typeface="Calibri"/>
+              </a:rPr>
+              <a:t> · Random targeting</a:t>
             </a:r>
           </a:p>
         </p:txBody>
@@ -7637,6 +7770,7 @@
           <a:lstStyle/>
           <a:p>
             <a:pPr algn="ctr"/>
+            <a:endParaRPr/>
           </a:p>
         </p:txBody>
       </p:sp>
@@ -7681,6 +7815,7 @@
           <a:lstStyle/>
           <a:p>
             <a:pPr algn="ctr"/>
+            <a:endParaRPr/>
           </a:p>
         </p:txBody>
       </p:sp>
@@ -7693,7 +7828,7 @@
         <p:spPr>
           <a:xfrm>
             <a:off x="6489039" y="2249424"/>
-            <a:ext cx="4943703" cy="438086"/>
+            <a:ext cx="4943703" cy="332720"/>
           </a:xfrm>
           <a:prstGeom prst="rect">
             <a:avLst/>
@@ -7712,14 +7847,38 @@
               </a:lnSpc>
             </a:pPr>
             <a:r>
-              <a:rPr sz="1550" b="1" i="0">
+              <a:rPr lang="ru-RU" sz="1550" b="1" dirty="0">
                 <a:solidFill>
                   <a:srgbClr val="F2F4F7"/>
                 </a:solidFill>
                 <a:latin typeface="Calibri"/>
               </a:rPr>
-              <a:t>1 · Response CatBoost</a:t>
-            </a:r>
+              <a:t>2</a:t>
+            </a:r>
+            <a:r>
+              <a:rPr sz="1550" b="1" i="0" dirty="0">
+                <a:solidFill>
+                  <a:srgbClr val="F2F4F7"/>
+                </a:solidFill>
+                <a:latin typeface="Calibri"/>
+              </a:rPr>
+              <a:t> · Response </a:t>
+            </a:r>
+            <a:r>
+              <a:rPr sz="1550" b="1" i="0" dirty="0" err="1">
+                <a:solidFill>
+                  <a:srgbClr val="F2F4F7"/>
+                </a:solidFill>
+                <a:latin typeface="Calibri"/>
+              </a:rPr>
+              <a:t>CatBoost</a:t>
+            </a:r>
+            <a:endParaRPr sz="1550" b="1" i="0" dirty="0">
+              <a:solidFill>
+                <a:srgbClr val="F2F4F7"/>
+              </a:solidFill>
+              <a:latin typeface="Calibri"/>
+            </a:endParaRPr>
           </a:p>
         </p:txBody>
       </p:sp>
@@ -7807,6 +7966,7 @@
           <a:lstStyle/>
           <a:p>
             <a:pPr algn="ctr"/>
+            <a:endParaRPr/>
           </a:p>
         </p:txBody>
       </p:sp>
@@ -7851,6 +8011,7 @@
           <a:lstStyle/>
           <a:p>
             <a:pPr algn="ctr"/>
+            <a:endParaRPr/>
           </a:p>
         </p:txBody>
       </p:sp>
@@ -7863,7 +8024,7 @@
         <p:spPr>
           <a:xfrm>
             <a:off x="758952" y="4123944"/>
-            <a:ext cx="4943703" cy="438086"/>
+            <a:ext cx="4943703" cy="332720"/>
           </a:xfrm>
           <a:prstGeom prst="rect">
             <a:avLst/>
@@ -7882,13 +8043,22 @@
               </a:lnSpc>
             </a:pPr>
             <a:r>
-              <a:rPr sz="1550" b="1" i="0">
+              <a:rPr lang="ru-RU" sz="1550" b="1" dirty="0">
                 <a:solidFill>
                   <a:srgbClr val="F2F4F7"/>
                 </a:solidFill>
                 <a:latin typeface="Calibri"/>
               </a:rPr>
-              <a:t>2 · T-Learner</a:t>
+              <a:t>3</a:t>
+            </a:r>
+            <a:r>
+              <a:rPr sz="1550" b="1" i="0" dirty="0">
+                <a:solidFill>
+                  <a:srgbClr val="F2F4F7"/>
+                </a:solidFill>
+                <a:latin typeface="Calibri"/>
+              </a:rPr>
+              <a:t> · T-Learner</a:t>
             </a:r>
           </a:p>
         </p:txBody>
@@ -7977,6 +8147,7 @@
           <a:lstStyle/>
           <a:p>
             <a:pPr algn="ctr"/>
+            <a:endParaRPr/>
           </a:p>
         </p:txBody>
       </p:sp>
@@ -8021,6 +8192,7 @@
           <a:lstStyle/>
           <a:p>
             <a:pPr algn="ctr"/>
+            <a:endParaRPr/>
           </a:p>
         </p:txBody>
       </p:sp>
@@ -8033,7 +8205,7 @@
         <p:spPr>
           <a:xfrm>
             <a:off x="6489039" y="4123944"/>
-            <a:ext cx="4943703" cy="438086"/>
+            <a:ext cx="4943703" cy="332720"/>
           </a:xfrm>
           <a:prstGeom prst="rect">
             <a:avLst/>
@@ -8052,13 +8224,22 @@
               </a:lnSpc>
             </a:pPr>
             <a:r>
-              <a:rPr sz="1550" b="1" i="0">
+              <a:rPr lang="ru-RU" sz="1550" b="1" dirty="0">
                 <a:solidFill>
                   <a:srgbClr val="F2F4F7"/>
                 </a:solidFill>
                 <a:latin typeface="Calibri"/>
               </a:rPr>
-              <a:t>3 · X-Learner</a:t>
+              <a:t>4 </a:t>
+            </a:r>
+            <a:r>
+              <a:rPr sz="1550" b="1" i="0" dirty="0">
+                <a:solidFill>
+                  <a:srgbClr val="F2F4F7"/>
+                </a:solidFill>
+                <a:latin typeface="Calibri"/>
+              </a:rPr>
+              <a:t>· X-Learner</a:t>
             </a:r>
           </a:p>
         </p:txBody>
@@ -8143,6 +8324,7 @@
           <a:lstStyle/>
           <a:p>
             <a:pPr algn="ctr"/>
+            <a:endParaRPr/>
           </a:p>
         </p:txBody>
       </p:sp>
@@ -8233,7 +8415,7 @@
 </file>
 
 <file path=ppt/slides/slide6.xml><?xml version="1.0" encoding="utf-8"?>
-<p:sld xmlns:a="http://schemas.openxmlformats.org/drawingml/2006/main" xmlns:p="http://schemas.openxmlformats.org/presentationml/2006/main" xmlns:r="http://schemas.openxmlformats.org/officeDocument/2006/relationships">
+<p:sld xmlns:a="http://schemas.openxmlformats.org/drawingml/2006/main" xmlns:r="http://schemas.openxmlformats.org/officeDocument/2006/relationships" xmlns:p="http://schemas.openxmlformats.org/presentationml/2006/main">
   <p:cSld>
     <p:bg>
       <p:bgPr>
@@ -8249,7 +8431,14 @@
         <p:cNvGrpSpPr/>
         <p:nvPr/>
       </p:nvGrpSpPr>
-      <p:grpSpPr/>
+      <p:grpSpPr>
+        <a:xfrm>
+          <a:off x="0" y="0"/>
+          <a:ext cx="0" cy="0"/>
+          <a:chOff x="0" y="0"/>
+          <a:chExt cx="0" cy="0"/>
+        </a:xfrm>
+      </p:grpSpPr>
       <p:sp>
         <p:nvSpPr>
           <p:cNvPr id="2" name="Rectangle 1"/>
@@ -8291,6 +8480,7 @@
           <a:lstStyle/>
           <a:p>
             <a:pPr algn="ctr"/>
+            <a:endParaRPr/>
           </a:p>
         </p:txBody>
       </p:sp>
@@ -8448,7 +8638,7 @@
           </a:fontRef>
         </p:style>
         <p:txBody>
-          <a:bodyPr rtlCol="0" anchor="ctr" wrap="square"/>
+          <a:bodyPr wrap="square" rtlCol="0" anchor="ctr"/>
           <a:lstStyle/>
           <a:p>
             <a:pPr algn="ctr"/>
@@ -8506,6 +8696,7 @@
           <a:lstStyle/>
           <a:p>
             <a:pPr algn="ctr"/>
+            <a:endParaRPr/>
           </a:p>
         </p:txBody>
       </p:sp>
@@ -8546,7 +8737,7 @@
           </a:fontRef>
         </p:style>
         <p:txBody>
-          <a:bodyPr rtlCol="0" anchor="ctr" wrap="square"/>
+          <a:bodyPr wrap="square" rtlCol="0" anchor="ctr"/>
           <a:lstStyle/>
           <a:p>
             <a:pPr algn="ctr"/>
@@ -8604,6 +8795,7 @@
           <a:lstStyle/>
           <a:p>
             <a:pPr algn="ctr"/>
+            <a:endParaRPr/>
           </a:p>
         </p:txBody>
       </p:sp>
@@ -8644,7 +8836,7 @@
           </a:fontRef>
         </p:style>
         <p:txBody>
-          <a:bodyPr rtlCol="0" anchor="ctr" wrap="square"/>
+          <a:bodyPr wrap="square" rtlCol="0" anchor="ctr"/>
           <a:lstStyle/>
           <a:p>
             <a:pPr algn="ctr"/>
@@ -8702,6 +8894,7 @@
           <a:lstStyle/>
           <a:p>
             <a:pPr algn="ctr"/>
+            <a:endParaRPr/>
           </a:p>
         </p:txBody>
       </p:sp>
@@ -8742,7 +8935,7 @@
           </a:fontRef>
         </p:style>
         <p:txBody>
-          <a:bodyPr rtlCol="0" anchor="ctr" wrap="square"/>
+          <a:bodyPr wrap="square" rtlCol="0" anchor="ctr"/>
           <a:lstStyle/>
           <a:p>
             <a:pPr algn="ctr"/>
@@ -8796,7 +8989,7 @@
           </a:fontRef>
         </p:style>
         <p:txBody>
-          <a:bodyPr rtlCol="0" anchor="ctr" wrap="square"/>
+          <a:bodyPr wrap="square" rtlCol="0" anchor="ctr"/>
           <a:lstStyle/>
           <a:p>
             <a:pPr algn="ctr"/>
@@ -8850,7 +9043,7 @@
           </a:fontRef>
         </p:style>
         <p:txBody>
-          <a:bodyPr rtlCol="0" anchor="ctr" wrap="square"/>
+          <a:bodyPr wrap="square" rtlCol="0" anchor="ctr"/>
           <a:lstStyle/>
           <a:p>
             <a:pPr algn="ctr"/>
@@ -8908,6 +9101,7 @@
           <a:lstStyle/>
           <a:p>
             <a:pPr algn="ctr"/>
+            <a:endParaRPr/>
           </a:p>
         </p:txBody>
       </p:sp>
@@ -9011,6 +9205,7 @@
           <a:lstStyle/>
           <a:p>
             <a:pPr algn="ctr"/>
+            <a:endParaRPr/>
           </a:p>
         </p:txBody>
       </p:sp>
@@ -9055,6 +9250,7 @@
           <a:lstStyle/>
           <a:p>
             <a:pPr algn="ctr"/>
+            <a:endParaRPr/>
           </a:p>
         </p:txBody>
       </p:sp>
@@ -9105,7 +9301,7 @@
         </p:nvSpPr>
         <p:spPr>
           <a:xfrm>
-            <a:off x="758952" y="5699506"/>
+            <a:off x="758951" y="5607815"/>
             <a:ext cx="10673791" cy="411480"/>
           </a:xfrm>
           <a:prstGeom prst="rect">
@@ -9125,13 +9321,436 @@
               </a:lnSpc>
             </a:pPr>
             <a:r>
-              <a:rPr sz="1200" b="0" i="0">
-                <a:solidFill>
-                  <a:srgbClr val="A9B4C0"/>
-                </a:solidFill>
-                <a:latin typeface="Calibri"/>
-              </a:rPr>
-              <a:t>Сравнил распределения длин по трём уровням: на товарном истории оказались слишком длинными (p95=312, max=2513) — поэтому выбрал чек: он компактнее (p95=54) и при этом сохраняет реальную гранулярность похода в магазин.</a:t>
+              <a:rPr sz="1200" b="0" i="0" dirty="0" err="1">
+                <a:solidFill>
+                  <a:srgbClr val="A9B4C0"/>
+                </a:solidFill>
+                <a:latin typeface="Calibri"/>
+              </a:rPr>
+              <a:t>Сравнил</a:t>
+            </a:r>
+            <a:r>
+              <a:rPr sz="1200" b="0" i="0" dirty="0">
+                <a:solidFill>
+                  <a:srgbClr val="A9B4C0"/>
+                </a:solidFill>
+                <a:latin typeface="Calibri"/>
+              </a:rPr>
+              <a:t> </a:t>
+            </a:r>
+            <a:r>
+              <a:rPr sz="1200" b="0" i="0" dirty="0" err="1">
+                <a:solidFill>
+                  <a:srgbClr val="A9B4C0"/>
+                </a:solidFill>
+                <a:latin typeface="Calibri"/>
+              </a:rPr>
+              <a:t>распределения</a:t>
+            </a:r>
+            <a:r>
+              <a:rPr sz="1200" b="0" i="0" dirty="0">
+                <a:solidFill>
+                  <a:srgbClr val="A9B4C0"/>
+                </a:solidFill>
+                <a:latin typeface="Calibri"/>
+              </a:rPr>
+              <a:t> </a:t>
+            </a:r>
+            <a:r>
+              <a:rPr sz="1200" b="0" i="0" dirty="0" err="1">
+                <a:solidFill>
+                  <a:srgbClr val="A9B4C0"/>
+                </a:solidFill>
+                <a:latin typeface="Calibri"/>
+              </a:rPr>
+              <a:t>длин</a:t>
+            </a:r>
+            <a:r>
+              <a:rPr sz="1200" b="0" i="0" dirty="0">
+                <a:solidFill>
+                  <a:srgbClr val="A9B4C0"/>
+                </a:solidFill>
+                <a:latin typeface="Calibri"/>
+              </a:rPr>
+              <a:t> </a:t>
+            </a:r>
+            <a:r>
+              <a:rPr sz="1200" b="0" i="0" dirty="0" err="1">
+                <a:solidFill>
+                  <a:srgbClr val="A9B4C0"/>
+                </a:solidFill>
+                <a:latin typeface="Calibri"/>
+              </a:rPr>
+              <a:t>по</a:t>
+            </a:r>
+            <a:r>
+              <a:rPr sz="1200" b="0" i="0" dirty="0">
+                <a:solidFill>
+                  <a:srgbClr val="A9B4C0"/>
+                </a:solidFill>
+                <a:latin typeface="Calibri"/>
+              </a:rPr>
+              <a:t> </a:t>
+            </a:r>
+            <a:r>
+              <a:rPr sz="1200" b="0" i="0" dirty="0" err="1">
+                <a:solidFill>
+                  <a:srgbClr val="A9B4C0"/>
+                </a:solidFill>
+                <a:latin typeface="Calibri"/>
+              </a:rPr>
+              <a:t>трём</a:t>
+            </a:r>
+            <a:r>
+              <a:rPr sz="1200" b="0" i="0" dirty="0">
+                <a:solidFill>
+                  <a:srgbClr val="A9B4C0"/>
+                </a:solidFill>
+                <a:latin typeface="Calibri"/>
+              </a:rPr>
+              <a:t> </a:t>
+            </a:r>
+            <a:r>
+              <a:rPr sz="1200" b="0" i="0" dirty="0" err="1">
+                <a:solidFill>
+                  <a:srgbClr val="A9B4C0"/>
+                </a:solidFill>
+                <a:latin typeface="Calibri"/>
+              </a:rPr>
+              <a:t>уровням</a:t>
+            </a:r>
+            <a:r>
+              <a:rPr sz="1200" b="0" i="0" dirty="0">
+                <a:solidFill>
+                  <a:srgbClr val="A9B4C0"/>
+                </a:solidFill>
+                <a:latin typeface="Calibri"/>
+              </a:rPr>
+              <a:t>: </a:t>
+            </a:r>
+            <a:r>
+              <a:rPr sz="1200" b="0" i="0" dirty="0" err="1">
+                <a:solidFill>
+                  <a:srgbClr val="A9B4C0"/>
+                </a:solidFill>
+                <a:latin typeface="Calibri"/>
+              </a:rPr>
+              <a:t>на</a:t>
+            </a:r>
+            <a:r>
+              <a:rPr sz="1200" b="0" i="0" dirty="0">
+                <a:solidFill>
+                  <a:srgbClr val="A9B4C0"/>
+                </a:solidFill>
+                <a:latin typeface="Calibri"/>
+              </a:rPr>
+              <a:t> </a:t>
+            </a:r>
+            <a:r>
+              <a:rPr sz="1200" b="0" i="0" dirty="0" err="1">
+                <a:solidFill>
+                  <a:srgbClr val="A9B4C0"/>
+                </a:solidFill>
+                <a:latin typeface="Calibri"/>
+              </a:rPr>
+              <a:t>товарном</a:t>
+            </a:r>
+            <a:r>
+              <a:rPr sz="1200" b="0" i="0" dirty="0">
+                <a:solidFill>
+                  <a:srgbClr val="A9B4C0"/>
+                </a:solidFill>
+                <a:latin typeface="Calibri"/>
+              </a:rPr>
+              <a:t> </a:t>
+            </a:r>
+            <a:r>
+              <a:rPr sz="1200" b="0" i="0" dirty="0" err="1">
+                <a:solidFill>
+                  <a:srgbClr val="A9B4C0"/>
+                </a:solidFill>
+                <a:latin typeface="Calibri"/>
+              </a:rPr>
+              <a:t>истории</a:t>
+            </a:r>
+            <a:r>
+              <a:rPr sz="1200" b="0" i="0" dirty="0">
+                <a:solidFill>
+                  <a:srgbClr val="A9B4C0"/>
+                </a:solidFill>
+                <a:latin typeface="Calibri"/>
+              </a:rPr>
+              <a:t> </a:t>
+            </a:r>
+            <a:r>
+              <a:rPr sz="1200" b="0" i="0" dirty="0" err="1">
+                <a:solidFill>
+                  <a:srgbClr val="A9B4C0"/>
+                </a:solidFill>
+                <a:latin typeface="Calibri"/>
+              </a:rPr>
+              <a:t>оказались</a:t>
+            </a:r>
+            <a:r>
+              <a:rPr sz="1200" b="0" i="0" dirty="0">
+                <a:solidFill>
+                  <a:srgbClr val="A9B4C0"/>
+                </a:solidFill>
+                <a:latin typeface="Calibri"/>
+              </a:rPr>
+              <a:t> </a:t>
+            </a:r>
+            <a:r>
+              <a:rPr sz="1200" b="0" i="0" dirty="0" err="1">
+                <a:solidFill>
+                  <a:srgbClr val="A9B4C0"/>
+                </a:solidFill>
+                <a:latin typeface="Calibri"/>
+              </a:rPr>
+              <a:t>слишком</a:t>
+            </a:r>
+            <a:r>
+              <a:rPr sz="1200" b="0" i="0" dirty="0">
+                <a:solidFill>
+                  <a:srgbClr val="A9B4C0"/>
+                </a:solidFill>
+                <a:latin typeface="Calibri"/>
+              </a:rPr>
+              <a:t> </a:t>
+            </a:r>
+            <a:r>
+              <a:rPr sz="1200" b="0" i="0" dirty="0" err="1">
+                <a:solidFill>
+                  <a:srgbClr val="A9B4C0"/>
+                </a:solidFill>
+                <a:latin typeface="Calibri"/>
+              </a:rPr>
+              <a:t>длинными</a:t>
+            </a:r>
+            <a:r>
+              <a:rPr sz="1200" b="0" i="0" dirty="0">
+                <a:solidFill>
+                  <a:srgbClr val="A9B4C0"/>
+                </a:solidFill>
+                <a:latin typeface="Calibri"/>
+              </a:rPr>
+              <a:t> (p95=312, max=2513) — </a:t>
+            </a:r>
+            <a:r>
+              <a:rPr sz="1200" b="0" i="0" dirty="0" err="1">
+                <a:solidFill>
+                  <a:srgbClr val="A9B4C0"/>
+                </a:solidFill>
+                <a:latin typeface="Calibri"/>
+              </a:rPr>
+              <a:t>поэтому</a:t>
+            </a:r>
+            <a:r>
+              <a:rPr sz="1200" b="0" i="0" dirty="0">
+                <a:solidFill>
+                  <a:srgbClr val="A9B4C0"/>
+                </a:solidFill>
+                <a:latin typeface="Calibri"/>
+              </a:rPr>
+              <a:t> </a:t>
+            </a:r>
+            <a:r>
+              <a:rPr sz="1200" b="0" i="0" dirty="0" err="1">
+                <a:solidFill>
+                  <a:srgbClr val="A9B4C0"/>
+                </a:solidFill>
+                <a:latin typeface="Calibri"/>
+              </a:rPr>
+              <a:t>выбрал</a:t>
+            </a:r>
+            <a:r>
+              <a:rPr sz="1200" b="0" i="0" dirty="0">
+                <a:solidFill>
+                  <a:srgbClr val="A9B4C0"/>
+                </a:solidFill>
+                <a:latin typeface="Calibri"/>
+              </a:rPr>
+              <a:t> </a:t>
+            </a:r>
+            <a:r>
+              <a:rPr sz="1200" b="0" i="0" dirty="0" err="1">
+                <a:solidFill>
+                  <a:srgbClr val="A9B4C0"/>
+                </a:solidFill>
+                <a:latin typeface="Calibri"/>
+              </a:rPr>
+              <a:t>чек</a:t>
+            </a:r>
+            <a:r>
+              <a:rPr sz="1200" b="0" i="0" dirty="0">
+                <a:solidFill>
+                  <a:srgbClr val="A9B4C0"/>
+                </a:solidFill>
+                <a:latin typeface="Calibri"/>
+              </a:rPr>
+              <a:t>: </a:t>
+            </a:r>
+            <a:r>
+              <a:rPr sz="1200" b="0" i="0" dirty="0" err="1">
+                <a:solidFill>
+                  <a:srgbClr val="A9B4C0"/>
+                </a:solidFill>
+                <a:latin typeface="Calibri"/>
+              </a:rPr>
+              <a:t>он</a:t>
+            </a:r>
+            <a:r>
+              <a:rPr sz="1200" b="0" i="0" dirty="0">
+                <a:solidFill>
+                  <a:srgbClr val="A9B4C0"/>
+                </a:solidFill>
+                <a:latin typeface="Calibri"/>
+              </a:rPr>
+              <a:t> </a:t>
+            </a:r>
+            <a:r>
+              <a:rPr sz="1200" b="0" i="0" dirty="0" err="1">
+                <a:solidFill>
+                  <a:srgbClr val="A9B4C0"/>
+                </a:solidFill>
+                <a:latin typeface="Calibri"/>
+              </a:rPr>
+              <a:t>компактнее</a:t>
+            </a:r>
+            <a:r>
+              <a:rPr sz="1200" b="0" i="0" dirty="0">
+                <a:solidFill>
+                  <a:srgbClr val="A9B4C0"/>
+                </a:solidFill>
+                <a:latin typeface="Calibri"/>
+              </a:rPr>
+              <a:t> (p95=54) и </a:t>
+            </a:r>
+            <a:r>
+              <a:rPr sz="1200" b="0" i="0" dirty="0" err="1">
+                <a:solidFill>
+                  <a:srgbClr val="A9B4C0"/>
+                </a:solidFill>
+                <a:latin typeface="Calibri"/>
+              </a:rPr>
+              <a:t>при</a:t>
+            </a:r>
+            <a:r>
+              <a:rPr sz="1200" b="0" i="0" dirty="0">
+                <a:solidFill>
+                  <a:srgbClr val="A9B4C0"/>
+                </a:solidFill>
+                <a:latin typeface="Calibri"/>
+              </a:rPr>
+              <a:t> </a:t>
+            </a:r>
+            <a:r>
+              <a:rPr sz="1200" b="0" i="0" dirty="0" err="1">
+                <a:solidFill>
+                  <a:srgbClr val="A9B4C0"/>
+                </a:solidFill>
+                <a:latin typeface="Calibri"/>
+              </a:rPr>
+              <a:t>этом</a:t>
+            </a:r>
+            <a:r>
+              <a:rPr sz="1200" b="0" i="0" dirty="0">
+                <a:solidFill>
+                  <a:srgbClr val="A9B4C0"/>
+                </a:solidFill>
+                <a:latin typeface="Calibri"/>
+              </a:rPr>
+              <a:t> </a:t>
+            </a:r>
+            <a:r>
+              <a:rPr sz="1200" b="0" i="0" dirty="0" err="1">
+                <a:solidFill>
+                  <a:srgbClr val="A9B4C0"/>
+                </a:solidFill>
+                <a:latin typeface="Calibri"/>
+              </a:rPr>
+              <a:t>сохраняет</a:t>
+            </a:r>
+            <a:r>
+              <a:rPr sz="1200" b="0" i="0" dirty="0">
+                <a:solidFill>
+                  <a:srgbClr val="A9B4C0"/>
+                </a:solidFill>
+                <a:latin typeface="Calibri"/>
+              </a:rPr>
+              <a:t> </a:t>
+            </a:r>
+            <a:r>
+              <a:rPr sz="1200" b="0" i="0" dirty="0" err="1">
+                <a:solidFill>
+                  <a:srgbClr val="A9B4C0"/>
+                </a:solidFill>
+                <a:latin typeface="Calibri"/>
+              </a:rPr>
+              <a:t>реальную</a:t>
+            </a:r>
+            <a:r>
+              <a:rPr sz="1200" b="0" i="0" dirty="0">
+                <a:solidFill>
+                  <a:srgbClr val="A9B4C0"/>
+                </a:solidFill>
+                <a:latin typeface="Calibri"/>
+              </a:rPr>
+              <a:t> </a:t>
+            </a:r>
+            <a:r>
+              <a:rPr sz="1200" b="0" i="0" dirty="0" err="1">
+                <a:solidFill>
+                  <a:srgbClr val="A9B4C0"/>
+                </a:solidFill>
+                <a:latin typeface="Calibri"/>
+              </a:rPr>
+              <a:t>гранулярность</a:t>
+            </a:r>
+            <a:r>
+              <a:rPr sz="1200" b="0" i="0" dirty="0">
+                <a:solidFill>
+                  <a:srgbClr val="A9B4C0"/>
+                </a:solidFill>
+                <a:latin typeface="Calibri"/>
+              </a:rPr>
+              <a:t> </a:t>
+            </a:r>
+            <a:r>
+              <a:rPr sz="1200" b="0" i="0" dirty="0" err="1">
+                <a:solidFill>
+                  <a:srgbClr val="A9B4C0"/>
+                </a:solidFill>
+                <a:latin typeface="Calibri"/>
+              </a:rPr>
+              <a:t>похода</a:t>
+            </a:r>
+            <a:r>
+              <a:rPr sz="1200" b="0" i="0" dirty="0">
+                <a:solidFill>
+                  <a:srgbClr val="A9B4C0"/>
+                </a:solidFill>
+                <a:latin typeface="Calibri"/>
+              </a:rPr>
+              <a:t> в </a:t>
+            </a:r>
+            <a:r>
+              <a:rPr sz="1200" b="0" i="0" dirty="0" err="1">
+                <a:solidFill>
+                  <a:srgbClr val="A9B4C0"/>
+                </a:solidFill>
+                <a:latin typeface="Calibri"/>
+              </a:rPr>
+              <a:t>магазин</a:t>
+            </a:r>
+            <a:r>
+              <a:rPr sz="1200" b="0" i="0" dirty="0">
+                <a:solidFill>
+                  <a:srgbClr val="A9B4C0"/>
+                </a:solidFill>
+                <a:latin typeface="Calibri"/>
+              </a:rPr>
+              <a:t>.</a:t>
             </a:r>
           </a:p>
         </p:txBody>
@@ -9177,6 +9796,7 @@
           <a:lstStyle/>
           <a:p>
             <a:pPr algn="ctr"/>
+            <a:endParaRPr/>
           </a:p>
         </p:txBody>
       </p:sp>
@@ -9267,7 +9887,7 @@
 </file>
 
 <file path=ppt/slides/slide7.xml><?xml version="1.0" encoding="utf-8"?>
-<p:sld xmlns:a="http://schemas.openxmlformats.org/drawingml/2006/main" xmlns:p="http://schemas.openxmlformats.org/presentationml/2006/main" xmlns:r="http://schemas.openxmlformats.org/officeDocument/2006/relationships">
+<p:sld xmlns:a="http://schemas.openxmlformats.org/drawingml/2006/main" xmlns:r="http://schemas.openxmlformats.org/officeDocument/2006/relationships" xmlns:p="http://schemas.openxmlformats.org/presentationml/2006/main">
   <p:cSld>
     <p:bg>
       <p:bgPr>
@@ -9283,7 +9903,14 @@
         <p:cNvGrpSpPr/>
         <p:nvPr/>
       </p:nvGrpSpPr>
-      <p:grpSpPr/>
+      <p:grpSpPr>
+        <a:xfrm>
+          <a:off x="0" y="0"/>
+          <a:ext cx="0" cy="0"/>
+          <a:chOff x="0" y="0"/>
+          <a:chExt cx="0" cy="0"/>
+        </a:xfrm>
+      </p:grpSpPr>
       <p:sp>
         <p:nvSpPr>
           <p:cNvPr id="2" name="Rectangle 1"/>
@@ -9325,6 +9952,7 @@
           <a:lstStyle/>
           <a:p>
             <a:pPr algn="ctr"/>
+            <a:endParaRPr/>
           </a:p>
         </p:txBody>
       </p:sp>
@@ -9471,7 +10099,7 @@
         </p:nvGraphicFramePr>
         <p:xfrm>
           <a:off x="502920" y="2514600"/>
-          <a:ext cx="5486400" cy="2240280"/>
+          <a:ext cx="5486400" cy="2339340"/>
         </p:xfrm>
         <a:graphic>
           <a:graphicData uri="http://schemas.openxmlformats.org/drawingml/2006/table">
@@ -9480,10 +10108,34 @@
                 <a:tableStyleId>{5C22544A-7EE6-4342-B048-85BDC9FD1C3A}</a:tableStyleId>
               </a:tblPr>
               <a:tblGrid>
-                <a:gridCol w="1371600"/>
-                <a:gridCol w="1371600"/>
-                <a:gridCol w="1371600"/>
-                <a:gridCol w="1371600"/>
+                <a:gridCol w="1371600">
+                  <a:extLst>
+                    <a:ext uri="{9D8B030D-6E8A-4147-A177-3AD203B41FA5}">
+                      <a16:colId xmlns:a16="http://schemas.microsoft.com/office/drawing/2014/main" val="20000"/>
+                    </a:ext>
+                  </a:extLst>
+                </a:gridCol>
+                <a:gridCol w="1371600">
+                  <a:extLst>
+                    <a:ext uri="{9D8B030D-6E8A-4147-A177-3AD203B41FA5}">
+                      <a16:colId xmlns:a16="http://schemas.microsoft.com/office/drawing/2014/main" val="20001"/>
+                    </a:ext>
+                  </a:extLst>
+                </a:gridCol>
+                <a:gridCol w="1371600">
+                  <a:extLst>
+                    <a:ext uri="{9D8B030D-6E8A-4147-A177-3AD203B41FA5}">
+                      <a16:colId xmlns:a16="http://schemas.microsoft.com/office/drawing/2014/main" val="20002"/>
+                    </a:ext>
+                  </a:extLst>
+                </a:gridCol>
+                <a:gridCol w="1371600">
+                  <a:extLst>
+                    <a:ext uri="{9D8B030D-6E8A-4147-A177-3AD203B41FA5}">
+                      <a16:colId xmlns:a16="http://schemas.microsoft.com/office/drawing/2014/main" val="20003"/>
+                    </a:ext>
+                  </a:extLst>
+                </a:gridCol>
               </a:tblGrid>
               <a:tr h="373380">
                 <a:tc>
@@ -9493,7 +10145,7 @@
                     <a:p>
                       <a:pPr algn="ctr"/>
                       <a:r>
-                        <a:rPr b="1" sz="1350">
+                        <a:rPr sz="1350" b="1">
                           <a:solidFill>
                             <a:srgbClr val="F2F4F7"/>
                           </a:solidFill>
@@ -9516,7 +10168,7 @@
                     <a:p>
                       <a:pPr algn="ctr"/>
                       <a:r>
-                        <a:rPr b="1" sz="1350">
+                        <a:rPr sz="1350" b="1">
                           <a:solidFill>
                             <a:srgbClr val="F2F4F7"/>
                           </a:solidFill>
@@ -9539,7 +10191,7 @@
                     <a:p>
                       <a:pPr algn="ctr"/>
                       <a:r>
-                        <a:rPr b="1" sz="1350">
+                        <a:rPr sz="1350" b="1">
                           <a:solidFill>
                             <a:srgbClr val="F2F4F7"/>
                           </a:solidFill>
@@ -9562,7 +10214,7 @@
                     <a:p>
                       <a:pPr algn="ctr"/>
                       <a:r>
-                        <a:rPr b="1" sz="1350">
+                        <a:rPr sz="1350" b="1">
                           <a:solidFill>
                             <a:srgbClr val="F2F4F7"/>
                           </a:solidFill>
@@ -9578,6 +10230,11 @@
                     </a:solidFill>
                   </a:tcPr>
                 </a:tc>
+                <a:extLst>
+                  <a:ext uri="{0D108BD9-81ED-4DB2-BD59-A6C34878D82A}">
+                    <a16:rowId xmlns:a16="http://schemas.microsoft.com/office/drawing/2014/main" val="10000"/>
+                  </a:ext>
+                </a:extLst>
               </a:tr>
               <a:tr h="373380">
                 <a:tc>
@@ -9672,6 +10329,11 @@
                     </a:solidFill>
                   </a:tcPr>
                 </a:tc>
+                <a:extLst>
+                  <a:ext uri="{0D108BD9-81ED-4DB2-BD59-A6C34878D82A}">
+                    <a16:rowId xmlns:a16="http://schemas.microsoft.com/office/drawing/2014/main" val="10001"/>
+                  </a:ext>
+                </a:extLst>
               </a:tr>
               <a:tr h="373380">
                 <a:tc>
@@ -9766,6 +10428,11 @@
                     </a:solidFill>
                   </a:tcPr>
                 </a:tc>
+                <a:extLst>
+                  <a:ext uri="{0D108BD9-81ED-4DB2-BD59-A6C34878D82A}">
+                    <a16:rowId xmlns:a16="http://schemas.microsoft.com/office/drawing/2014/main" val="10002"/>
+                  </a:ext>
+                </a:extLst>
               </a:tr>
               <a:tr h="373380">
                 <a:tc>
@@ -9860,6 +10527,11 @@
                     </a:solidFill>
                   </a:tcPr>
                 </a:tc>
+                <a:extLst>
+                  <a:ext uri="{0D108BD9-81ED-4DB2-BD59-A6C34878D82A}">
+                    <a16:rowId xmlns:a16="http://schemas.microsoft.com/office/drawing/2014/main" val="10003"/>
+                  </a:ext>
+                </a:extLst>
               </a:tr>
               <a:tr h="373380">
                 <a:tc>
@@ -9954,6 +10626,11 @@
                     </a:solidFill>
                   </a:tcPr>
                 </a:tc>
+                <a:extLst>
+                  <a:ext uri="{0D108BD9-81ED-4DB2-BD59-A6C34878D82A}">
+                    <a16:rowId xmlns:a16="http://schemas.microsoft.com/office/drawing/2014/main" val="10004"/>
+                  </a:ext>
+                </a:extLst>
               </a:tr>
               <a:tr h="373380">
                 <a:tc>
@@ -10048,6 +10725,11 @@
                     </a:solidFill>
                   </a:tcPr>
                 </a:tc>
+                <a:extLst>
+                  <a:ext uri="{0D108BD9-81ED-4DB2-BD59-A6C34878D82A}">
+                    <a16:rowId xmlns:a16="http://schemas.microsoft.com/office/drawing/2014/main" val="10005"/>
+                  </a:ext>
+                </a:extLst>
               </a:tr>
             </a:tbl>
           </a:graphicData>
@@ -10122,6 +10804,7 @@
           <a:lstStyle/>
           <a:p>
             <a:pPr algn="ctr"/>
+            <a:endParaRPr/>
           </a:p>
         </p:txBody>
       </p:sp>
@@ -10166,6 +10849,7 @@
           <a:lstStyle/>
           <a:p>
             <a:pPr algn="ctr"/>
+            <a:endParaRPr/>
           </a:p>
         </p:txBody>
       </p:sp>
@@ -10288,6 +10972,7 @@
           <a:lstStyle/>
           <a:p>
             <a:pPr algn="ctr"/>
+            <a:endParaRPr/>
           </a:p>
         </p:txBody>
       </p:sp>
@@ -10378,7 +11063,7 @@
 </file>
 
 <file path=ppt/slides/slide8.xml><?xml version="1.0" encoding="utf-8"?>
-<p:sld xmlns:a="http://schemas.openxmlformats.org/drawingml/2006/main" xmlns:p="http://schemas.openxmlformats.org/presentationml/2006/main" xmlns:r="http://schemas.openxmlformats.org/officeDocument/2006/relationships">
+<p:sld xmlns:a="http://schemas.openxmlformats.org/drawingml/2006/main" xmlns:r="http://schemas.openxmlformats.org/officeDocument/2006/relationships" xmlns:p="http://schemas.openxmlformats.org/presentationml/2006/main">
   <p:cSld>
     <p:bg>
       <p:bgPr>
@@ -10394,7 +11079,14 @@
         <p:cNvGrpSpPr/>
         <p:nvPr/>
       </p:nvGrpSpPr>
-      <p:grpSpPr/>
+      <p:grpSpPr>
+        <a:xfrm>
+          <a:off x="0" y="0"/>
+          <a:ext cx="0" cy="0"/>
+          <a:chOff x="0" y="0"/>
+          <a:chExt cx="0" cy="0"/>
+        </a:xfrm>
+      </p:grpSpPr>
       <p:sp>
         <p:nvSpPr>
           <p:cNvPr id="2" name="Rectangle 1"/>
@@ -10436,6 +11128,7 @@
           <a:lstStyle/>
           <a:p>
             <a:pPr algn="ctr"/>
+            <a:endParaRPr/>
           </a:p>
         </p:txBody>
       </p:sp>
@@ -10625,6 +11318,7 @@
           <a:lstStyle/>
           <a:p>
             <a:pPr algn="ctr"/>
+            <a:endParaRPr/>
           </a:p>
         </p:txBody>
       </p:sp>
@@ -10669,6 +11363,7 @@
           <a:lstStyle/>
           <a:p>
             <a:pPr algn="ctr"/>
+            <a:endParaRPr/>
           </a:p>
         </p:txBody>
       </p:sp>
@@ -10795,6 +11490,7 @@
           <a:lstStyle/>
           <a:p>
             <a:pPr algn="ctr"/>
+            <a:endParaRPr/>
           </a:p>
         </p:txBody>
       </p:sp>
@@ -10839,6 +11535,7 @@
           <a:lstStyle/>
           <a:p>
             <a:pPr algn="ctr"/>
+            <a:endParaRPr/>
           </a:p>
         </p:txBody>
       </p:sp>
@@ -10965,6 +11662,7 @@
           <a:lstStyle/>
           <a:p>
             <a:pPr algn="ctr"/>
+            <a:endParaRPr/>
           </a:p>
         </p:txBody>
       </p:sp>
@@ -11009,6 +11707,7 @@
           <a:lstStyle/>
           <a:p>
             <a:pPr algn="ctr"/>
+            <a:endParaRPr/>
           </a:p>
         </p:txBody>
       </p:sp>
@@ -11131,6 +11830,7 @@
           <a:lstStyle/>
           <a:p>
             <a:pPr algn="ctr"/>
+            <a:endParaRPr/>
           </a:p>
         </p:txBody>
       </p:sp>
@@ -11221,7 +11921,7 @@
 </file>
 
 <file path=ppt/slides/slide9.xml><?xml version="1.0" encoding="utf-8"?>
-<p:sld xmlns:a="http://schemas.openxmlformats.org/drawingml/2006/main" xmlns:p="http://schemas.openxmlformats.org/presentationml/2006/main" xmlns:r="http://schemas.openxmlformats.org/officeDocument/2006/relationships">
+<p:sld xmlns:a="http://schemas.openxmlformats.org/drawingml/2006/main" xmlns:r="http://schemas.openxmlformats.org/officeDocument/2006/relationships" xmlns:p="http://schemas.openxmlformats.org/presentationml/2006/main">
   <p:cSld>
     <p:bg>
       <p:bgPr>
@@ -11237,7 +11937,14 @@
         <p:cNvGrpSpPr/>
         <p:nvPr/>
       </p:nvGrpSpPr>
-      <p:grpSpPr/>
+      <p:grpSpPr>
+        <a:xfrm>
+          <a:off x="0" y="0"/>
+          <a:ext cx="0" cy="0"/>
+          <a:chOff x="0" y="0"/>
+          <a:chExt cx="0" cy="0"/>
+        </a:xfrm>
+      </p:grpSpPr>
       <p:sp>
         <p:nvSpPr>
           <p:cNvPr id="2" name="Rectangle 1"/>
@@ -11279,6 +11986,7 @@
           <a:lstStyle/>
           <a:p>
             <a:pPr algn="ctr"/>
+            <a:endParaRPr/>
           </a:p>
         </p:txBody>
       </p:sp>
@@ -11444,6 +12152,7 @@
           <a:lstStyle/>
           <a:p>
             <a:pPr algn="ctr"/>
+            <a:endParaRPr/>
           </a:p>
         </p:txBody>
       </p:sp>
@@ -11488,6 +12197,7 @@
           <a:lstStyle/>
           <a:p>
             <a:pPr algn="ctr"/>
+            <a:endParaRPr/>
           </a:p>
         </p:txBody>
       </p:sp>
@@ -11614,6 +12324,7 @@
           <a:lstStyle/>
           <a:p>
             <a:pPr algn="ctr"/>
+            <a:endParaRPr/>
           </a:p>
         </p:txBody>
       </p:sp>
@@ -11658,6 +12369,7 @@
           <a:lstStyle/>
           <a:p>
             <a:pPr algn="ctr"/>
+            <a:endParaRPr/>
           </a:p>
         </p:txBody>
       </p:sp>
@@ -11784,6 +12496,7 @@
           <a:lstStyle/>
           <a:p>
             <a:pPr algn="ctr"/>
+            <a:endParaRPr/>
           </a:p>
         </p:txBody>
       </p:sp>
@@ -11828,6 +12541,7 @@
           <a:lstStyle/>
           <a:p>
             <a:pPr algn="ctr"/>
+            <a:endParaRPr/>
           </a:p>
         </p:txBody>
       </p:sp>
@@ -11878,7 +12592,7 @@
         </p:nvSpPr>
         <p:spPr>
           <a:xfrm>
-            <a:off x="6489039" y="2858516"/>
+            <a:off x="6432672" y="2663698"/>
             <a:ext cx="2078659" cy="2743200"/>
           </a:xfrm>
           <a:prstGeom prst="rect">
@@ -11898,13 +12612,355 @@
               </a:lnSpc>
             </a:pPr>
             <a:r>
-              <a:rPr sz="1250" b="0" i="0">
-                <a:solidFill>
-                  <a:srgbClr val="A9B4C0"/>
-                </a:solidFill>
-                <a:latin typeface="Calibri"/>
-              </a:rPr>
-              <a:t>ДИ не пересекает ноль, значит, модель значимо лучше случайного распределения — но при этом CPU-бюджете обучения всё же уступает табличным моделям.</a:t>
+              <a:rPr sz="1250" b="0" i="0" dirty="0">
+                <a:solidFill>
+                  <a:srgbClr val="A9B4C0"/>
+                </a:solidFill>
+                <a:latin typeface="Calibri"/>
+              </a:rPr>
+              <a:t>ДИ </a:t>
+            </a:r>
+            <a:r>
+              <a:rPr sz="1250" b="0" i="0" dirty="0" err="1">
+                <a:solidFill>
+                  <a:srgbClr val="A9B4C0"/>
+                </a:solidFill>
+                <a:latin typeface="Calibri"/>
+              </a:rPr>
+              <a:t>не</a:t>
+            </a:r>
+            <a:r>
+              <a:rPr sz="1250" b="0" i="0" dirty="0">
+                <a:solidFill>
+                  <a:srgbClr val="A9B4C0"/>
+                </a:solidFill>
+                <a:latin typeface="Calibri"/>
+              </a:rPr>
+              <a:t> </a:t>
+            </a:r>
+            <a:r>
+              <a:rPr sz="1250" b="0" i="0" dirty="0" err="1">
+                <a:solidFill>
+                  <a:srgbClr val="A9B4C0"/>
+                </a:solidFill>
+                <a:latin typeface="Calibri"/>
+              </a:rPr>
+              <a:t>пересекает</a:t>
+            </a:r>
+            <a:r>
+              <a:rPr sz="1250" b="0" i="0" dirty="0">
+                <a:solidFill>
+                  <a:srgbClr val="A9B4C0"/>
+                </a:solidFill>
+                <a:latin typeface="Calibri"/>
+              </a:rPr>
+              <a:t> </a:t>
+            </a:r>
+            <a:r>
+              <a:rPr sz="1250" b="0" i="0" dirty="0" err="1">
+                <a:solidFill>
+                  <a:srgbClr val="A9B4C0"/>
+                </a:solidFill>
+                <a:latin typeface="Calibri"/>
+              </a:rPr>
+              <a:t>ноль</a:t>
+            </a:r>
+            <a:r>
+              <a:rPr sz="1250" b="0" i="0" dirty="0">
+                <a:solidFill>
+                  <a:srgbClr val="A9B4C0"/>
+                </a:solidFill>
+                <a:latin typeface="Calibri"/>
+              </a:rPr>
+              <a:t>, </a:t>
+            </a:r>
+            <a:r>
+              <a:rPr sz="1250" b="0" i="0" dirty="0" err="1">
+                <a:solidFill>
+                  <a:srgbClr val="A9B4C0"/>
+                </a:solidFill>
+                <a:latin typeface="Calibri"/>
+              </a:rPr>
+              <a:t>значит</a:t>
+            </a:r>
+            <a:r>
+              <a:rPr sz="1250" b="0" i="0" dirty="0">
+                <a:solidFill>
+                  <a:srgbClr val="A9B4C0"/>
+                </a:solidFill>
+                <a:latin typeface="Calibri"/>
+              </a:rPr>
+              <a:t>, </a:t>
+            </a:r>
+            <a:r>
+              <a:rPr sz="1250" b="0" i="0" dirty="0" err="1">
+                <a:solidFill>
+                  <a:srgbClr val="A9B4C0"/>
+                </a:solidFill>
+                <a:latin typeface="Calibri"/>
+              </a:rPr>
+              <a:t>модель</a:t>
+            </a:r>
+            <a:r>
+              <a:rPr sz="1250" b="0" i="0" dirty="0">
+                <a:solidFill>
+                  <a:srgbClr val="A9B4C0"/>
+                </a:solidFill>
+                <a:latin typeface="Calibri"/>
+              </a:rPr>
+              <a:t> </a:t>
+            </a:r>
+            <a:r>
+              <a:rPr sz="1250" b="0" i="0" dirty="0" err="1">
+                <a:solidFill>
+                  <a:srgbClr val="A9B4C0"/>
+                </a:solidFill>
+                <a:latin typeface="Calibri"/>
+              </a:rPr>
+              <a:t>значимо</a:t>
+            </a:r>
+            <a:r>
+              <a:rPr sz="1250" b="0" i="0" dirty="0">
+                <a:solidFill>
+                  <a:srgbClr val="A9B4C0"/>
+                </a:solidFill>
+                <a:latin typeface="Calibri"/>
+              </a:rPr>
+              <a:t> </a:t>
+            </a:r>
+            <a:r>
+              <a:rPr sz="1250" b="0" i="0" dirty="0" err="1">
+                <a:solidFill>
+                  <a:srgbClr val="A9B4C0"/>
+                </a:solidFill>
+                <a:latin typeface="Calibri"/>
+              </a:rPr>
+              <a:t>лучше</a:t>
+            </a:r>
+            <a:r>
+              <a:rPr sz="1250" b="0" i="0" dirty="0">
+                <a:solidFill>
+                  <a:srgbClr val="A9B4C0"/>
+                </a:solidFill>
+                <a:latin typeface="Calibri"/>
+              </a:rPr>
+              <a:t> </a:t>
+            </a:r>
+            <a:r>
+              <a:rPr sz="1250" b="0" i="0" dirty="0" err="1">
+                <a:solidFill>
+                  <a:srgbClr val="A9B4C0"/>
+                </a:solidFill>
+                <a:latin typeface="Calibri"/>
+              </a:rPr>
+              <a:t>случайного</a:t>
+            </a:r>
+            <a:r>
+              <a:rPr sz="1250" b="0" i="0" dirty="0">
+                <a:solidFill>
+                  <a:srgbClr val="A9B4C0"/>
+                </a:solidFill>
+                <a:latin typeface="Calibri"/>
+              </a:rPr>
+              <a:t> </a:t>
+            </a:r>
+            <a:r>
+              <a:rPr sz="1250" b="0" i="0" dirty="0" err="1">
+                <a:solidFill>
+                  <a:srgbClr val="A9B4C0"/>
+                </a:solidFill>
+                <a:latin typeface="Calibri"/>
+              </a:rPr>
+              <a:t>распределения</a:t>
+            </a:r>
+            <a:r>
+              <a:rPr sz="1250" b="0" i="0" dirty="0">
+                <a:solidFill>
+                  <a:srgbClr val="A9B4C0"/>
+                </a:solidFill>
+                <a:latin typeface="Calibri"/>
+              </a:rPr>
+              <a:t> — </a:t>
+            </a:r>
+            <a:r>
+              <a:rPr sz="1250" b="0" i="0" dirty="0" err="1">
+                <a:solidFill>
+                  <a:srgbClr val="A9B4C0"/>
+                </a:solidFill>
+                <a:latin typeface="Calibri"/>
+              </a:rPr>
+              <a:t>но</a:t>
+            </a:r>
+            <a:r>
+              <a:rPr sz="1250" b="0" i="0" dirty="0">
+                <a:solidFill>
+                  <a:srgbClr val="A9B4C0"/>
+                </a:solidFill>
+                <a:latin typeface="Calibri"/>
+              </a:rPr>
+              <a:t> </a:t>
+            </a:r>
+            <a:r>
+              <a:rPr sz="1250" b="0" i="0" dirty="0" err="1">
+                <a:solidFill>
+                  <a:srgbClr val="A9B4C0"/>
+                </a:solidFill>
+                <a:latin typeface="Calibri"/>
+              </a:rPr>
+              <a:t>при</a:t>
+            </a:r>
+            <a:r>
+              <a:rPr sz="1250" b="0" i="0" dirty="0">
+                <a:solidFill>
+                  <a:srgbClr val="A9B4C0"/>
+                </a:solidFill>
+                <a:latin typeface="Calibri"/>
+              </a:rPr>
+              <a:t> </a:t>
+            </a:r>
+            <a:r>
+              <a:rPr sz="1250" b="0" i="0" dirty="0" err="1">
+                <a:solidFill>
+                  <a:srgbClr val="A9B4C0"/>
+                </a:solidFill>
+                <a:latin typeface="Calibri"/>
+              </a:rPr>
+              <a:t>этом</a:t>
+            </a:r>
+            <a:r>
+              <a:rPr sz="1250" b="0" i="0" dirty="0">
+                <a:solidFill>
+                  <a:srgbClr val="A9B4C0"/>
+                </a:solidFill>
+                <a:latin typeface="Calibri"/>
+              </a:rPr>
+              <a:t> CPU-</a:t>
+            </a:r>
+            <a:r>
+              <a:rPr sz="1250" b="0" i="0" dirty="0" err="1">
+                <a:solidFill>
+                  <a:srgbClr val="A9B4C0"/>
+                </a:solidFill>
+                <a:latin typeface="Calibri"/>
+              </a:rPr>
+              <a:t>бюджете</a:t>
+            </a:r>
+            <a:r>
+              <a:rPr sz="1250" b="0" i="0" dirty="0">
+                <a:solidFill>
+                  <a:srgbClr val="A9B4C0"/>
+                </a:solidFill>
+                <a:latin typeface="Calibri"/>
+              </a:rPr>
+              <a:t> </a:t>
+            </a:r>
+            <a:r>
+              <a:rPr sz="1250" b="0" i="0" dirty="0" err="1">
+                <a:solidFill>
+                  <a:srgbClr val="A9B4C0"/>
+                </a:solidFill>
+                <a:latin typeface="Calibri"/>
+              </a:rPr>
+              <a:t>обучения</a:t>
+            </a:r>
+            <a:r>
+              <a:rPr sz="1250" b="0" i="0" dirty="0">
+                <a:solidFill>
+                  <a:srgbClr val="A9B4C0"/>
+                </a:solidFill>
+                <a:latin typeface="Calibri"/>
+              </a:rPr>
+              <a:t> </a:t>
+            </a:r>
+            <a:r>
+              <a:rPr sz="1250" b="0" i="0" dirty="0" err="1">
+                <a:solidFill>
+                  <a:srgbClr val="A9B4C0"/>
+                </a:solidFill>
+                <a:latin typeface="Calibri"/>
+              </a:rPr>
+              <a:t>всё</a:t>
+            </a:r>
+            <a:r>
+              <a:rPr sz="1250" b="0" i="0" dirty="0">
+                <a:solidFill>
+                  <a:srgbClr val="A9B4C0"/>
+                </a:solidFill>
+                <a:latin typeface="Calibri"/>
+              </a:rPr>
+              <a:t> </a:t>
+            </a:r>
+            <a:r>
+              <a:rPr sz="1250" b="0" i="0" dirty="0" err="1">
+                <a:solidFill>
+                  <a:srgbClr val="A9B4C0"/>
+                </a:solidFill>
+                <a:latin typeface="Calibri"/>
+              </a:rPr>
+              <a:t>же</a:t>
+            </a:r>
+            <a:r>
+              <a:rPr sz="1250" b="0" i="0" dirty="0">
+                <a:solidFill>
+                  <a:srgbClr val="A9B4C0"/>
+                </a:solidFill>
+                <a:latin typeface="Calibri"/>
+              </a:rPr>
+              <a:t> </a:t>
+            </a:r>
+            <a:r>
+              <a:rPr sz="1250" b="0" i="0" dirty="0" err="1">
+                <a:solidFill>
+                  <a:srgbClr val="A9B4C0"/>
+                </a:solidFill>
+                <a:latin typeface="Calibri"/>
+              </a:rPr>
+              <a:t>уступает</a:t>
+            </a:r>
+            <a:r>
+              <a:rPr sz="1250" b="0" i="0" dirty="0">
+                <a:solidFill>
+                  <a:srgbClr val="A9B4C0"/>
+                </a:solidFill>
+                <a:latin typeface="Calibri"/>
+              </a:rPr>
+              <a:t> </a:t>
+            </a:r>
+            <a:r>
+              <a:rPr sz="1250" b="0" i="0" dirty="0" err="1">
+                <a:solidFill>
+                  <a:srgbClr val="A9B4C0"/>
+                </a:solidFill>
+                <a:latin typeface="Calibri"/>
+              </a:rPr>
+              <a:t>табличным</a:t>
+            </a:r>
+            <a:r>
+              <a:rPr sz="1250" b="0" i="0" dirty="0">
+                <a:solidFill>
+                  <a:srgbClr val="A9B4C0"/>
+                </a:solidFill>
+                <a:latin typeface="Calibri"/>
+              </a:rPr>
+              <a:t> </a:t>
+            </a:r>
+            <a:r>
+              <a:rPr sz="1250" b="0" i="0" dirty="0" err="1">
+                <a:solidFill>
+                  <a:srgbClr val="A9B4C0"/>
+                </a:solidFill>
+                <a:latin typeface="Calibri"/>
+              </a:rPr>
+              <a:t>моделям</a:t>
+            </a:r>
+            <a:r>
+              <a:rPr sz="1250" b="0" i="0" dirty="0">
+                <a:solidFill>
+                  <a:srgbClr val="A9B4C0"/>
+                </a:solidFill>
+                <a:latin typeface="Calibri"/>
+              </a:rPr>
+              <a:t>.</a:t>
             </a:r>
           </a:p>
         </p:txBody>
@@ -11954,6 +13010,7 @@
           <a:lstStyle/>
           <a:p>
             <a:pPr algn="ctr"/>
+            <a:endParaRPr/>
           </a:p>
         </p:txBody>
       </p:sp>
@@ -11998,6 +13055,7 @@
           <a:lstStyle/>
           <a:p>
             <a:pPr algn="ctr"/>
+            <a:endParaRPr/>
           </a:p>
         </p:txBody>
       </p:sp>
@@ -12120,6 +13178,7 @@
           <a:lstStyle/>
           <a:p>
             <a:pPr algn="ctr"/>
+            <a:endParaRPr/>
           </a:p>
         </p:txBody>
       </p:sp>

</xml_diff>

<commit_message>
Add Docker/CI for Development & Engineering criterion
- Dockerfile + requirements-docker.txt (excludes Windows-only pywin32,
  which cannot install in a Linux container -- used only by the
  PowerPoint COM automation script, not the ML pipeline itself)
- .github/workflows/tests.yml runs pytest on push/PR
- Updated docs/itmo_requirements.md status table to reflect actual state
  (was stale "planned" placeholders from project start)

Note: the Docker image was authored carefully but not build-tested in
this session (Docker Desktop wasn't started, per user's request).

Co-Authored-By: Claude Sonnet 5 <noreply@anthropic.com>
</commit_message>
<xml_diff>
--- a/presentation/presentation.pptx
+++ b/presentation/presentation.pptx
@@ -13107,7 +13107,7 @@
         <p:spPr>
           <a:xfrm>
             <a:off x="9354083" y="2636266"/>
-            <a:ext cx="2078659" cy="2743200"/>
+            <a:ext cx="2078659" cy="1329210"/>
           </a:xfrm>
           <a:prstGeom prst="rect">
             <a:avLst/>
@@ -13126,14 +13126,56 @@
               </a:lnSpc>
             </a:pPr>
             <a:r>
-              <a:rPr sz="1250" b="0" i="0">
-                <a:solidFill>
-                  <a:srgbClr val="A9B4C0"/>
-                </a:solidFill>
-                <a:latin typeface="Calibri"/>
-              </a:rPr>
-              <a:t>Онлайн A/B-эксперимент, больший бюджет обучения Transformer, MLOps-пайплайн для продакшна.</a:t>
-            </a:r>
+              <a:rPr lang="ru-RU" sz="1250" b="0" i="0" dirty="0">
+                <a:solidFill>
+                  <a:srgbClr val="A9B4C0"/>
+                </a:solidFill>
+                <a:latin typeface="Calibri"/>
+              </a:rPr>
+              <a:t>Онлайн A/B-эксперимент, больший бюджет обучения </a:t>
+            </a:r>
+            <a:r>
+              <a:rPr lang="ru-RU" sz="1250" b="0" i="0" dirty="0" err="1">
+                <a:solidFill>
+                  <a:srgbClr val="A9B4C0"/>
+                </a:solidFill>
+                <a:latin typeface="Calibri"/>
+              </a:rPr>
+              <a:t>Transformer</a:t>
+            </a:r>
+            <a:r>
+              <a:rPr lang="ru-RU" sz="1250" b="0" i="0" dirty="0">
+                <a:solidFill>
+                  <a:srgbClr val="A9B4C0"/>
+                </a:solidFill>
+                <a:latin typeface="Calibri"/>
+              </a:rPr>
+              <a:t>, углубление в теорию </a:t>
+            </a:r>
+            <a:r>
+              <a:rPr lang="ru-RU" sz="1250" b="0" i="0" dirty="0" err="1">
+                <a:solidFill>
+                  <a:srgbClr val="A9B4C0"/>
+                </a:solidFill>
+                <a:latin typeface="Calibri"/>
+              </a:rPr>
+              <a:t>Transformer</a:t>
+            </a:r>
+            <a:r>
+              <a:rPr lang="ru-RU" sz="1250" b="0" i="0" dirty="0">
+                <a:solidFill>
+                  <a:srgbClr val="A9B4C0"/>
+                </a:solidFill>
+                <a:latin typeface="Calibri"/>
+              </a:rPr>
+              <a:t>-архитектур и других современных подходов.</a:t>
+            </a:r>
+            <a:endParaRPr sz="1250" b="0" i="0" dirty="0">
+              <a:solidFill>
+                <a:srgbClr val="A9B4C0"/>
+              </a:solidFill>
+              <a:latin typeface="Calibri"/>
+            </a:endParaRPr>
           </a:p>
         </p:txBody>
       </p:sp>

</xml_diff>